<commit_message>
fix: support phrase corrections and long-silence review boundaries
</commit_message>
<xml_diff>
--- a/progress/sprint_2/sprint_2_increment_demo.pptx
+++ b/progress/sprint_2/sprint_2_increment_demo.pptx
@@ -1053,7 +1053,7 @@
 </file>
 
 <file path=ppt/notesSlides/notesSlide18.xml><?xml version="1.0" encoding="utf-8"?>
-<p:notes xmlns:p="http://schemas.openxmlformats.org/presentationml/2006/main">
+<p:notes xmlns:a="http://schemas.openxmlformats.org/drawingml/2006/main" xmlns:p="http://schemas.openxmlformats.org/presentationml/2006/main">
   <p:cSld>
     <p:spTree>
       <p:nvGrpSpPr>
@@ -1062,13 +1062,13 @@
         <p:nvPr/>
       </p:nvGrpSpPr>
       <p:grpSpPr>
-        <a:xfrm xmlns:a="http://schemas.openxmlformats.org/drawingml/2006/main"/>
+        <a:xfrm/>
       </p:grpSpPr>
       <p:sp>
         <p:nvSpPr>
           <p:cNvPr id="2" name="Slide Image Placeholder 1"/>
           <p:cNvSpPr>
-            <a:spLocks xmlns:a="http://schemas.openxmlformats.org/drawingml/2006/main" noGrp="1"/>
+            <a:spLocks noGrp="1"/>
           </p:cNvSpPr>
           <p:nvPr>
             <p:ph type="sldImg" idx="0"/>
@@ -1080,7 +1080,7 @@
         <p:nvSpPr>
           <p:cNvPr id="3" name="Notes Placeholder 2"/>
           <p:cNvSpPr>
-            <a:spLocks xmlns:a="http://schemas.openxmlformats.org/drawingml/2006/main" noGrp="1"/>
+            <a:spLocks noGrp="1"/>
           </p:cNvSpPr>
           <p:nvPr>
             <p:ph type="body" idx="1"/>
@@ -1088,11 +1088,11 @@
         </p:nvSpPr>
         <p:spPr/>
         <p:txBody>
-          <a:bodyPr xmlns:a="http://schemas.openxmlformats.org/drawingml/2006/main"/>
-          <a:lstStyle xmlns:a="http://schemas.openxmlformats.org/drawingml/2006/main"/>
-          <a:p xmlns:a="http://schemas.openxmlformats.org/drawingml/2006/main">
-            <a:r>
-              <a:t>Evidence: tests/cleanup_configuration_20261004.json and reading_blocks_configured_20261004.json. Explicit variants on a disposable copy produced 802 sourceParts blocks, 32 blocks with a 15-second cap and 6 blocks with a 1.5-second gap cutoff. Default produced 4. These are grouping metrics, not ASR or speaker accuracy gains. Limits are seconds. Reject nonfinite and negative values, a nonpositive duration cap, or one-sided gap greater than neighbor gap. Semantic continuity and independent acoustic boundary reassessment remain unimplemented.</a:t>
+          <a:bodyPr/>
+          <a:lstStyle/>
+          <a:p>
+            <a:r>
+              <a:t>The prior unlimited same-speaker default merged a 33.28-second gap between segment_104 ending at 148.40 s and segment_105 starting at 181.68 s. Product Owner directed a new segment and parameter. longSilenceBoundarySeconds defaults to 10 seconds, finite and positive; gap &gt;= threshold splits even with same speaker. Missing/null older fields inherit 10. maximumReadingGapSeconds remains optional for stricter cuts; maximumReadingBlockSeconds stays null, so there is no 15-second duration cap. This is a configurable temporal boundary, not semantic topic detection. UT-21/IT-16 cover threshold equality, old decoding, invalid settings, saved corrections and CLI persistence. Eleven controls are documented in transcript_segmentation.md and demo/segmentation-settings.json. The earlier 32-to-four measurement is historical and no longer describes current default grouping. Native slider seeking and listening remain live checks. Evidence: tests/long_silence_review_20261004.json.</a:t>
             </a:r>
           </a:p>
         </p:txBody>
@@ -1101,7 +1101,7 @@
         <p:nvSpPr>
           <p:cNvPr id="4" name="Slide Number Placeholder 3"/>
           <p:cNvSpPr>
-            <a:spLocks xmlns:a="http://schemas.openxmlformats.org/drawingml/2006/main" noGrp="1"/>
+            <a:spLocks noGrp="1"/>
           </p:cNvSpPr>
           <p:nvPr>
             <p:ph type="sldNum" idx="5"/>
@@ -1109,21 +1109,21 @@
         </p:nvSpPr>
         <p:spPr/>
         <p:txBody>
-          <a:bodyPr xmlns:a="http://schemas.openxmlformats.org/drawingml/2006/main"/>
-          <a:lstStyle xmlns:a="http://schemas.openxmlformats.org/drawingml/2006/main"/>
-          <a:p xmlns:a="http://schemas.openxmlformats.org/drawingml/2006/main"/>
+          <a:bodyPr/>
+          <a:lstStyle/>
+          <a:p/>
         </p:txBody>
       </p:sp>
     </p:spTree>
   </p:cSld>
   <p:clrMapOvr>
-    <a:masterClrMapping xmlns:a="http://schemas.openxmlformats.org/drawingml/2006/main"/>
+    <a:masterClrMapping/>
   </p:clrMapOvr>
 </p:notes>
 </file>
 
 <file path=ppt/notesSlides/notesSlide19.xml><?xml version="1.0" encoding="utf-8"?>
-<p:notes xmlns:p="http://schemas.openxmlformats.org/presentationml/2006/main">
+<p:notes xmlns:a="http://schemas.openxmlformats.org/drawingml/2006/main" xmlns:p="http://schemas.openxmlformats.org/presentationml/2006/main">
   <p:cSld>
     <p:spTree>
       <p:nvGrpSpPr>
@@ -1132,13 +1132,13 @@
         <p:nvPr/>
       </p:nvGrpSpPr>
       <p:grpSpPr>
-        <a:xfrm xmlns:a="http://schemas.openxmlformats.org/drawingml/2006/main"/>
+        <a:xfrm/>
       </p:grpSpPr>
       <p:sp>
         <p:nvSpPr>
           <p:cNvPr id="2" name="Slide Image Placeholder 1"/>
           <p:cNvSpPr>
-            <a:spLocks xmlns:a="http://schemas.openxmlformats.org/drawingml/2006/main" noGrp="1"/>
+            <a:spLocks noGrp="1"/>
           </p:cNvSpPr>
           <p:nvPr>
             <p:ph type="sldImg" idx="0"/>
@@ -1150,7 +1150,7 @@
         <p:nvSpPr>
           <p:cNvPr id="3" name="Notes Placeholder 2"/>
           <p:cNvSpPr>
-            <a:spLocks xmlns:a="http://schemas.openxmlformats.org/drawingml/2006/main" noGrp="1"/>
+            <a:spLocks noGrp="1"/>
           </p:cNvSpPr>
           <p:nvPr>
             <p:ph type="body" idx="1"/>
@@ -1158,11 +1158,11 @@
         </p:nvSpPr>
         <p:spPr/>
         <p:txBody>
-          <a:bodyPr xmlns:a="http://schemas.openxmlformats.org/drawingml/2006/main"/>
-          <a:lstStyle xmlns:a="http://schemas.openxmlformats.org/drawingml/2006/main"/>
-          <a:p xmlns:a="http://schemas.openxmlformats.org/drawingml/2006/main">
-            <a:r>
-              <a:t>Evidence: sprint_2_implementation.md; ami_asr_benchmark.md; tests/cleanup_configuration_20261004.json; tests/po_demo_rehearsal_20261004.md. ASR Word Error Rate is the selected full AMI headset recording, Parakeet v2 versus Whisper base.en. Polish feasibility includes real Sejm transcription and qualitative official-PDF comparison, not a whole-meeting Word Error Rate claim. The configured Sejm grouping check used a copy of record 5C00CCF3-A242-4FB0-845D-92C6D30D7633. All 802 raw parts and reading words survived. The later grouping policy did not rerun the earlier LLM trials. Resource evidence: tests/multistage_minutes_trial_20261004.md and its AMI/Sejm metrics. Child-process peak RSS was 16.01 GB and 17.34 GB. Runs took 24.981 s and 53.410 s, respectively. Single observations, not deployment sizing guarantees.</a:t>
+          <a:bodyPr/>
+          <a:lstStyle/>
+          <a:p>
+            <a:r>
+              <a:t>Evidence: sprint_2_implementation.md; ami_asr_benchmark.md; tests/long_silence_review_20261004.json; tests/po_demo_rehearsal_20261004.md. Historical unlimited same-speaker grouping changed 32 blocks to four and preserved 802 source parts, but the later owner review found a 33.28-second pause wrongly merged. The new threshold splits it while preserving labels, words and corrections. This is reading behavior, not ASR accuracy. AMI Word Error Rate values and 30B resource measurements retain their original model/input scope. Peak child-process RSS 16.01 GB for AMI and 17.34 GB for Sejm, single observations. Model quality failures remain open.</a:t>
             </a:r>
           </a:p>
         </p:txBody>
@@ -1171,7 +1171,7 @@
         <p:nvSpPr>
           <p:cNvPr id="4" name="Slide Number Placeholder 3"/>
           <p:cNvSpPr>
-            <a:spLocks xmlns:a="http://schemas.openxmlformats.org/drawingml/2006/main" noGrp="1"/>
+            <a:spLocks noGrp="1"/>
           </p:cNvSpPr>
           <p:nvPr>
             <p:ph type="sldNum" idx="5"/>
@@ -1179,21 +1179,21 @@
         </p:nvSpPr>
         <p:spPr/>
         <p:txBody>
-          <a:bodyPr xmlns:a="http://schemas.openxmlformats.org/drawingml/2006/main"/>
-          <a:lstStyle xmlns:a="http://schemas.openxmlformats.org/drawingml/2006/main"/>
-          <a:p xmlns:a="http://schemas.openxmlformats.org/drawingml/2006/main"/>
+          <a:bodyPr/>
+          <a:lstStyle/>
+          <a:p/>
         </p:txBody>
       </p:sp>
     </p:spTree>
   </p:cSld>
   <p:clrMapOvr>
-    <a:masterClrMapping xmlns:a="http://schemas.openxmlformats.org/drawingml/2006/main"/>
+    <a:masterClrMapping/>
   </p:clrMapOvr>
 </p:notes>
 </file>
 
 <file path=ppt/notesSlides/notesSlide2.xml><?xml version="1.0" encoding="utf-8"?>
-<p:notes xmlns:p="http://schemas.openxmlformats.org/presentationml/2006/main">
+<p:notes xmlns:a="http://schemas.openxmlformats.org/drawingml/2006/main" xmlns:p="http://schemas.openxmlformats.org/presentationml/2006/main">
   <p:cSld>
     <p:spTree>
       <p:nvGrpSpPr>
@@ -1202,13 +1202,13 @@
         <p:nvPr/>
       </p:nvGrpSpPr>
       <p:grpSpPr>
-        <a:xfrm xmlns:a="http://schemas.openxmlformats.org/drawingml/2006/main"/>
+        <a:xfrm/>
       </p:grpSpPr>
       <p:sp>
         <p:nvSpPr>
           <p:cNvPr id="2" name="Slide Image Placeholder 1"/>
           <p:cNvSpPr>
-            <a:spLocks xmlns:a="http://schemas.openxmlformats.org/drawingml/2006/main" noGrp="1"/>
+            <a:spLocks noGrp="1"/>
           </p:cNvSpPr>
           <p:nvPr>
             <p:ph type="sldImg" idx="0"/>
@@ -1220,7 +1220,7 @@
         <p:nvSpPr>
           <p:cNvPr id="3" name="Notes Placeholder 2"/>
           <p:cNvSpPr>
-            <a:spLocks xmlns:a="http://schemas.openxmlformats.org/drawingml/2006/main" noGrp="1"/>
+            <a:spLocks noGrp="1"/>
           </p:cNvSpPr>
           <p:nvPr>
             <p:ph type="body" idx="1"/>
@@ -1228,11 +1228,11 @@
         </p:nvSpPr>
         <p:spPr/>
         <p:txBody>
-          <a:bodyPr xmlns:a="http://schemas.openxmlformats.org/drawingml/2006/main"/>
-          <a:lstStyle xmlns:a="http://schemas.openxmlformats.org/drawingml/2006/main"/>
-          <a:p xmlns:a="http://schemas.openxmlformats.org/drawingml/2006/main">
-            <a:r>
-              <a:t>Sources: PLAN.md Sprint 2; progress/sprint_2/sprint_2_design.md; progress/sprint_2/sprint_2_product_owner_presentation.md.</a:t>
+          <a:bodyPr/>
+          <a:lstStyle/>
+          <a:p>
+            <a:r>
+              <a:t>Sources: PLAN.md Sprint 2; progress/sprint_2/sprint_2_design.md; progress/sprint_2/sprint_2_increment_demo.md.</a:t>
             </a:r>
           </a:p>
         </p:txBody>
@@ -1241,7 +1241,7 @@
         <p:nvSpPr>
           <p:cNvPr id="4" name="Slide Number Placeholder 3"/>
           <p:cNvSpPr>
-            <a:spLocks xmlns:a="http://schemas.openxmlformats.org/drawingml/2006/main" noGrp="1"/>
+            <a:spLocks noGrp="1"/>
           </p:cNvSpPr>
           <p:nvPr>
             <p:ph type="sldNum" idx="5"/>
@@ -1249,15 +1249,15 @@
         </p:nvSpPr>
         <p:spPr/>
         <p:txBody>
-          <a:bodyPr xmlns:a="http://schemas.openxmlformats.org/drawingml/2006/main"/>
-          <a:lstStyle xmlns:a="http://schemas.openxmlformats.org/drawingml/2006/main"/>
-          <a:p xmlns:a="http://schemas.openxmlformats.org/drawingml/2006/main"/>
+          <a:bodyPr/>
+          <a:lstStyle/>
+          <a:p/>
         </p:txBody>
       </p:sp>
     </p:spTree>
   </p:cSld>
   <p:clrMapOvr>
-    <a:masterClrMapping xmlns:a="http://schemas.openxmlformats.org/drawingml/2006/main"/>
+    <a:masterClrMapping/>
   </p:clrMapOvr>
 </p:notes>
 </file>
@@ -1333,7 +1333,7 @@
 </file>
 
 <file path=ppt/notesSlides/notesSlide21.xml><?xml version="1.0" encoding="utf-8"?>
-<p:notes xmlns:p="http://schemas.openxmlformats.org/presentationml/2006/main">
+<p:notes xmlns:a="http://schemas.openxmlformats.org/drawingml/2006/main" xmlns:p="http://schemas.openxmlformats.org/presentationml/2006/main">
   <p:cSld>
     <p:spTree>
       <p:nvGrpSpPr>
@@ -1342,13 +1342,13 @@
         <p:nvPr/>
       </p:nvGrpSpPr>
       <p:grpSpPr>
-        <a:xfrm xmlns:a="http://schemas.openxmlformats.org/drawingml/2006/main"/>
+        <a:xfrm/>
       </p:grpSpPr>
       <p:sp>
         <p:nvSpPr>
           <p:cNvPr id="2" name="Slide Image Placeholder 1"/>
           <p:cNvSpPr>
-            <a:spLocks xmlns:a="http://schemas.openxmlformats.org/drawingml/2006/main" noGrp="1"/>
+            <a:spLocks noGrp="1"/>
           </p:cNvSpPr>
           <p:nvPr>
             <p:ph type="sldImg" idx="0"/>
@@ -1360,7 +1360,7 @@
         <p:nvSpPr>
           <p:cNvPr id="3" name="Notes Placeholder 2"/>
           <p:cNvSpPr>
-            <a:spLocks xmlns:a="http://schemas.openxmlformats.org/drawingml/2006/main" noGrp="1"/>
+            <a:spLocks noGrp="1"/>
           </p:cNvSpPr>
           <p:nvPr>
             <p:ph type="body" idx="1"/>
@@ -1368,11 +1368,11 @@
         </p:nvSpPr>
         <p:spPr/>
         <p:txBody>
-          <a:bodyPr xmlns:a="http://schemas.openxmlformats.org/drawingml/2006/main"/>
-          <a:lstStyle xmlns:a="http://schemas.openxmlformats.org/drawingml/2006/main"/>
-          <a:p xmlns:a="http://schemas.openxmlformats.org/drawingml/2006/main">
-            <a:r>
-              <a:t>Conclusions and proposed priorities follow existing Sprint 2 evidence and the planned Sprint 3 assessment. Sources: PLAN.md Sprint 3 PBI-012 through PBI-016; sprint_2_product_owner_presentation.md; tests/multistage_minutes_trial_20261004.md; ami_asr_benchmark.md; transcript_segmentation.md. These directions are recommendations for evidence analysis, not newly assigned PBIs or an accepted new implementation scope. The live Product Owner demonstration, documentation approval and sprint-close decision remain pending. The prototype supports investigation and source review, but the minutes content does not meet acceptance.</a:t>
+          <a:bodyPr/>
+          <a:lstStyle/>
+          <a:p>
+            <a:r>
+              <a:t>Conclusions follow Sprint 2 prototype evidence and the planned Sprint 3 assessment. Sources: PLAN.md; sprint_2_increment_demo.md; tests/multistage_minutes_trial_20261004.md; ami_asr_benchmark.md; transcript_segmentation.md; tests/long_silence_review_20261004.json. The directed long-silence repair now prevents the demonstrated same-speaker merge, but semantic continuity and voice reassessment remain unimplemented. Recommendations are not newly assigned PBIs. Live operator slider/audio checks, reliable minutes, documentation approval and sprint-close decision remain pending.</a:t>
             </a:r>
           </a:p>
         </p:txBody>
@@ -1381,7 +1381,7 @@
         <p:nvSpPr>
           <p:cNvPr id="4" name="Slide Number Placeholder 3"/>
           <p:cNvSpPr>
-            <a:spLocks xmlns:a="http://schemas.openxmlformats.org/drawingml/2006/main" noGrp="1"/>
+            <a:spLocks noGrp="1"/>
           </p:cNvSpPr>
           <p:nvPr>
             <p:ph type="sldNum" idx="5"/>
@@ -1389,15 +1389,15 @@
         </p:nvSpPr>
         <p:spPr/>
         <p:txBody>
-          <a:bodyPr xmlns:a="http://schemas.openxmlformats.org/drawingml/2006/main"/>
-          <a:lstStyle xmlns:a="http://schemas.openxmlformats.org/drawingml/2006/main"/>
-          <a:p xmlns:a="http://schemas.openxmlformats.org/drawingml/2006/main"/>
+          <a:bodyPr/>
+          <a:lstStyle/>
+          <a:p/>
         </p:txBody>
       </p:sp>
     </p:spTree>
   </p:cSld>
   <p:clrMapOvr>
-    <a:masterClrMapping xmlns:a="http://schemas.openxmlformats.org/drawingml/2006/main"/>
+    <a:masterClrMapping/>
   </p:clrMapOvr>
 </p:notes>
 </file>
@@ -1823,7 +1823,7 @@
 </file>
 
 <file path=ppt/notesSlides/notesSlide9.xml><?xml version="1.0" encoding="utf-8"?>
-<p:notes xmlns:p="http://schemas.openxmlformats.org/presentationml/2006/main">
+<p:notes xmlns:a="http://schemas.openxmlformats.org/drawingml/2006/main" xmlns:p="http://schemas.openxmlformats.org/presentationml/2006/main">
   <p:cSld>
     <p:spTree>
       <p:nvGrpSpPr>
@@ -1832,13 +1832,13 @@
         <p:nvPr/>
       </p:nvGrpSpPr>
       <p:grpSpPr>
-        <a:xfrm xmlns:a="http://schemas.openxmlformats.org/drawingml/2006/main"/>
+        <a:xfrm/>
       </p:grpSpPr>
       <p:sp>
         <p:nvSpPr>
           <p:cNvPr id="2" name="Slide Image Placeholder 1"/>
           <p:cNvSpPr>
-            <a:spLocks xmlns:a="http://schemas.openxmlformats.org/drawingml/2006/main" noGrp="1"/>
+            <a:spLocks noGrp="1"/>
           </p:cNvSpPr>
           <p:nvPr>
             <p:ph type="sldImg" idx="0"/>
@@ -1850,7 +1850,7 @@
         <p:nvSpPr>
           <p:cNvPr id="3" name="Notes Placeholder 2"/>
           <p:cNvSpPr>
-            <a:spLocks xmlns:a="http://schemas.openxmlformats.org/drawingml/2006/main" noGrp="1"/>
+            <a:spLocks noGrp="1"/>
           </p:cNvSpPr>
           <p:nvPr>
             <p:ph type="body" idx="1"/>
@@ -1858,11 +1858,11 @@
         </p:nvSpPr>
         <p:spPr/>
         <p:txBody>
-          <a:bodyPr xmlns:a="http://schemas.openxmlformats.org/drawingml/2006/main"/>
-          <a:lstStyle xmlns:a="http://schemas.openxmlformats.org/drawingml/2006/main"/>
-          <a:p xmlns:a="http://schemas.openxmlformats.org/drawingml/2006/main">
-            <a:r>
-              <a:t>The positive before/after/restore case is a controlled unit test, not a real-audio correction. Native UI automation could not attach to the launched review player. Do not assert that the developer heard or verified this audio.</a:t>
+          <a:bodyPr/>
+          <a:lstStyle/>
+          <a:p>
+            <a:r>
+              <a:t>Selected-text design accepted on 2026-10-04. BUG-6 exposed word-sized playback; BUG-7 exposed rejection of crossing corrections. Exact selected wording now changes while unselected words and superseded history stay saved. A saved native crossing edit was observed read-only in the Product Owner session: tests/selection_owner_session_20261004.json. All six selection_compatibility_verified gates passed at 20261004_230115. Source timing remains original-part resolution, with no invented replacement-word times. Context defaults to 2 seconds each side and is configurable. BUG-8 exposed a 33.28-second pause within the same S1 card. The directed repair adds a configurable long-silence boundary and a full-recording slider to both review and correction sheet. Dragging pauses/cancels bounded playback; release seeks; Play from position resumes. Demonstrate actual listening, scrubbing, Save, Restore, Cancel and restart. The separate QA-window launch was declined; native slider/audio verification remains pending. CLI shown is single-source only outside active ranges; range editing uses GUI. No ASR/LLM inference quality improvement is claimed. Evidence: sprint_2_tests.md; tests/selection_correction_review_20261004.json; tests/long_silence_review_20261004.json.</a:t>
             </a:r>
           </a:p>
         </p:txBody>
@@ -1871,7 +1871,7 @@
         <p:nvSpPr>
           <p:cNvPr id="4" name="Slide Number Placeholder 3"/>
           <p:cNvSpPr>
-            <a:spLocks xmlns:a="http://schemas.openxmlformats.org/drawingml/2006/main" noGrp="1"/>
+            <a:spLocks noGrp="1"/>
           </p:cNvSpPr>
           <p:nvPr>
             <p:ph type="sldNum" idx="5"/>
@@ -1879,15 +1879,15 @@
         </p:nvSpPr>
         <p:spPr/>
         <p:txBody>
-          <a:bodyPr xmlns:a="http://schemas.openxmlformats.org/drawingml/2006/main"/>
-          <a:lstStyle xmlns:a="http://schemas.openxmlformats.org/drawingml/2006/main"/>
-          <a:p xmlns:a="http://schemas.openxmlformats.org/drawingml/2006/main"/>
+          <a:bodyPr/>
+          <a:lstStyle/>
+          <a:p/>
         </p:txBody>
       </p:sp>
     </p:spTree>
   </p:cSld>
   <p:clrMapOvr>
-    <a:masterClrMapping xmlns:a="http://schemas.openxmlformats.org/drawingml/2006/main"/>
+    <a:masterClrMapping/>
   </p:clrMapOvr>
 </p:notes>
 </file>
@@ -6999,11 +6999,11 @@
 </file>
 
 <file path=ppt/slides/slide18.xml><?xml version="1.0" encoding="utf-8"?>
-<p:sld xmlns:p="http://schemas.openxmlformats.org/presentationml/2006/main">
+<p:sld xmlns:a="http://schemas.openxmlformats.org/drawingml/2006/main" xmlns:ns2="http://schemas.microsoft.com/office/drawing/2014/main" xmlns:ns3="http://schemas.microsoft.com/office/powerpoint/2010/main" xmlns:p="http://schemas.openxmlformats.org/presentationml/2006/main">
   <p:cSld>
     <p:bg>
       <p:bgPr>
-        <a:solidFill xmlns:a="http://schemas.openxmlformats.org/drawingml/2006/main">
+        <a:solidFill>
           <a:srgbClr val="FFFFFF"/>
         </a:solidFill>
       </p:bgPr>
@@ -7015,41 +7015,41 @@
         <p:nvPr/>
       </p:nvGrpSpPr>
       <p:grpSpPr>
-        <a:xfrm xmlns:a="http://schemas.openxmlformats.org/drawingml/2006/main"/>
+        <a:xfrm/>
       </p:grpSpPr>
       <p:sp>
         <p:nvSpPr>
           <p:cNvPr id="13" name="">
-            <a:extLst xmlns:a="http://schemas.openxmlformats.org/drawingml/2006/main">
-              <a:ext uri="{FF2B5EF4-FFF2-40B4-BE49-F238E27FC236}">
-                <a16:creationId xmlns:a16="http://schemas.microsoft.com/office/drawing/2014/main" id="{AFEE48B0-3E3A-4042-ACF0-F8E7560514A3}"/>
-              </a:ext>
-            </a:extLst>
-          </p:cNvPr>
-          <p:cNvSpPr>
-            <a:spLocks xmlns:a="http://schemas.openxmlformats.org/drawingml/2006/main" noGrp="1"/>
-          </p:cNvSpPr>
-          <p:nvPr/>
-        </p:nvSpPr>
-        <p:spPr>
-          <a:xfrm xmlns:a="http://schemas.openxmlformats.org/drawingml/2006/main">
+            <a:extLst>
+              <a:ext uri="{FF2B5EF4-FFF2-40B4-BE49-F238E27FC236}">
+                <ns2:creationId id="{AFEE48B0-3E3A-4042-ACF0-F8E7560514A3}"/>
+              </a:ext>
+            </a:extLst>
+          </p:cNvPr>
+          <p:cNvSpPr>
+            <a:spLocks noGrp="1"/>
+          </p:cNvSpPr>
+          <p:nvPr/>
+        </p:nvSpPr>
+        <p:spPr>
+          <a:xfrm>
             <a:off x="666750" y="438150"/>
             <a:ext cx="10858500" cy="704850"/>
           </a:xfrm>
-          <a:prstGeom xmlns:a="http://schemas.openxmlformats.org/drawingml/2006/main" prst="rect">
-            <a:avLst/>
-          </a:prstGeom>
-          <a:noFill xmlns:a="http://schemas.openxmlformats.org/drawingml/2006/main"/>
-          <a:ln xmlns:a="http://schemas.openxmlformats.org/drawingml/2006/main" w="0">
-            <a:noFill/>
-          </a:ln>
-        </p:spPr>
-        <p:txBody>
-          <a:bodyPr xmlns:a="http://schemas.openxmlformats.org/drawingml/2006/main">
-            <a:noAutofit/>
-          </a:bodyPr>
-          <a:lstStyle xmlns:a="http://schemas.openxmlformats.org/drawingml/2006/main"/>
-          <a:p xmlns:a="http://schemas.openxmlformats.org/drawingml/2006/main">
+          <a:prstGeom prst="rect">
+            <a:avLst/>
+          </a:prstGeom>
+          <a:noFill/>
+          <a:ln w="0">
+            <a:noFill/>
+          </a:ln>
+        </p:spPr>
+        <p:txBody>
+          <a:bodyPr>
+            <a:noAutofit/>
+          </a:bodyPr>
+          <a:lstStyle/>
+          <a:p>
             <a:pPr>
               <a:defRPr sz="3000" b="1">
                 <a:solidFill>
@@ -7077,36 +7077,36 @@
       <p:sp>
         <p:nvSpPr>
           <p:cNvPr id="2" name="">
-            <a:extLst xmlns:a="http://schemas.openxmlformats.org/drawingml/2006/main">
-              <a:ext uri="{FF2B5EF4-FFF2-40B4-BE49-F238E27FC236}">
-                <a16:creationId xmlns:a16="http://schemas.microsoft.com/office/drawing/2014/main" id="{A0A818AE-1878-4ED7-B9D1-55DEF6DE4C71}"/>
-              </a:ext>
-            </a:extLst>
-          </p:cNvPr>
-          <p:cNvSpPr>
-            <a:spLocks xmlns:a="http://schemas.openxmlformats.org/drawingml/2006/main" noGrp="1"/>
-          </p:cNvSpPr>
-          <p:nvPr/>
-        </p:nvSpPr>
-        <p:spPr>
-          <a:xfrm xmlns:a="http://schemas.openxmlformats.org/drawingml/2006/main">
+            <a:extLst>
+              <a:ext uri="{FF2B5EF4-FFF2-40B4-BE49-F238E27FC236}">
+                <ns2:creationId id="{A0A818AE-1878-4ED7-B9D1-55DEF6DE4C71}"/>
+              </a:ext>
+            </a:extLst>
+          </p:cNvPr>
+          <p:cNvSpPr>
+            <a:spLocks noGrp="1"/>
+          </p:cNvSpPr>
+          <p:nvPr/>
+        </p:nvSpPr>
+        <p:spPr>
+          <a:xfrm>
             <a:off x="742950" y="1438275"/>
             <a:ext cx="10668000" cy="323850"/>
           </a:xfrm>
-          <a:prstGeom xmlns:a="http://schemas.openxmlformats.org/drawingml/2006/main" prst="rect">
-            <a:avLst/>
-          </a:prstGeom>
-          <a:noFill xmlns:a="http://schemas.openxmlformats.org/drawingml/2006/main"/>
-          <a:ln xmlns:a="http://schemas.openxmlformats.org/drawingml/2006/main" w="0">
-            <a:noFill/>
-          </a:ln>
-        </p:spPr>
-        <p:txBody>
-          <a:bodyPr xmlns:a="http://schemas.openxmlformats.org/drawingml/2006/main">
-            <a:noAutofit/>
-          </a:bodyPr>
-          <a:lstStyle xmlns:a="http://schemas.openxmlformats.org/drawingml/2006/main"/>
-          <a:p xmlns:a="http://schemas.openxmlformats.org/drawingml/2006/main">
+          <a:prstGeom prst="rect">
+            <a:avLst/>
+          </a:prstGeom>
+          <a:noFill/>
+          <a:ln w="0">
+            <a:noFill/>
+          </a:ln>
+        </p:spPr>
+        <p:txBody>
+          <a:bodyPr>
+            <a:noAutofit/>
+          </a:bodyPr>
+          <a:lstStyle/>
+          <a:p>
             <a:pPr>
               <a:defRPr sz="2025" b="1">
                 <a:solidFill>
@@ -7134,36 +7134,36 @@
       <p:sp>
         <p:nvSpPr>
           <p:cNvPr id="3" name="">
-            <a:extLst xmlns:a="http://schemas.openxmlformats.org/drawingml/2006/main">
-              <a:ext uri="{FF2B5EF4-FFF2-40B4-BE49-F238E27FC236}">
-                <a16:creationId xmlns:a16="http://schemas.microsoft.com/office/drawing/2014/main" id="{3CAA5EA7-121B-47B7-A348-FD7920E59E94}"/>
-              </a:ext>
-            </a:extLst>
-          </p:cNvPr>
-          <p:cNvSpPr>
-            <a:spLocks xmlns:a="http://schemas.openxmlformats.org/drawingml/2006/main" noGrp="1"/>
-          </p:cNvSpPr>
-          <p:nvPr/>
-        </p:nvSpPr>
-        <p:spPr>
-          <a:xfrm xmlns:a="http://schemas.openxmlformats.org/drawingml/2006/main">
+            <a:extLst>
+              <a:ext uri="{FF2B5EF4-FFF2-40B4-BE49-F238E27FC236}">
+                <ns2:creationId id="{3CAA5EA7-121B-47B7-A348-FD7920E59E94}"/>
+              </a:ext>
+            </a:extLst>
+          </p:cNvPr>
+          <p:cNvSpPr>
+            <a:spLocks noGrp="1"/>
+          </p:cNvSpPr>
+          <p:nvPr/>
+        </p:nvSpPr>
+        <p:spPr>
+          <a:xfrm>
             <a:off x="742950" y="1809750"/>
             <a:ext cx="10668000" cy="476250"/>
           </a:xfrm>
-          <a:prstGeom xmlns:a="http://schemas.openxmlformats.org/drawingml/2006/main" prst="rect">
-            <a:avLst/>
-          </a:prstGeom>
-          <a:noFill xmlns:a="http://schemas.openxmlformats.org/drawingml/2006/main"/>
-          <a:ln xmlns:a="http://schemas.openxmlformats.org/drawingml/2006/main" w="0">
-            <a:noFill/>
-          </a:ln>
-        </p:spPr>
-        <p:txBody>
-          <a:bodyPr xmlns:a="http://schemas.openxmlformats.org/drawingml/2006/main">
-            <a:noAutofit/>
-          </a:bodyPr>
-          <a:lstStyle xmlns:a="http://schemas.openxmlformats.org/drawingml/2006/main"/>
-          <a:p xmlns:a="http://schemas.openxmlformats.org/drawingml/2006/main">
+          <a:prstGeom prst="rect">
+            <a:avLst/>
+          </a:prstGeom>
+          <a:noFill/>
+          <a:ln w="0">
+            <a:noFill/>
+          </a:ln>
+        </p:spPr>
+        <p:txBody>
+          <a:bodyPr>
+            <a:noAutofit/>
+          </a:bodyPr>
+          <a:lstStyle/>
+          <a:p>
             <a:pPr>
               <a:defRPr sz="1800" b="0">
                 <a:solidFill>
@@ -7191,36 +7191,36 @@
       <p:sp>
         <p:nvSpPr>
           <p:cNvPr id="4" name="">
-            <a:extLst xmlns:a="http://schemas.openxmlformats.org/drawingml/2006/main">
-              <a:ext uri="{FF2B5EF4-FFF2-40B4-BE49-F238E27FC236}">
-                <a16:creationId xmlns:a16="http://schemas.microsoft.com/office/drawing/2014/main" id="{353D033B-B14F-40CA-AFFC-6EE21900750E}"/>
-              </a:ext>
-            </a:extLst>
-          </p:cNvPr>
-          <p:cNvSpPr>
-            <a:spLocks xmlns:a="http://schemas.openxmlformats.org/drawingml/2006/main" noGrp="1"/>
-          </p:cNvSpPr>
-          <p:nvPr/>
-        </p:nvSpPr>
-        <p:spPr>
-          <a:xfrm xmlns:a="http://schemas.openxmlformats.org/drawingml/2006/main">
+            <a:extLst>
+              <a:ext uri="{FF2B5EF4-FFF2-40B4-BE49-F238E27FC236}">
+                <ns2:creationId id="{353D033B-B14F-40CA-AFFC-6EE21900750E}"/>
+              </a:ext>
+            </a:extLst>
+          </p:cNvPr>
+          <p:cNvSpPr>
+            <a:spLocks noGrp="1"/>
+          </p:cNvSpPr>
+          <p:nvPr/>
+        </p:nvSpPr>
+        <p:spPr>
+          <a:xfrm>
             <a:off x="742950" y="2362200"/>
             <a:ext cx="10668000" cy="323850"/>
           </a:xfrm>
-          <a:prstGeom xmlns:a="http://schemas.openxmlformats.org/drawingml/2006/main" prst="rect">
-            <a:avLst/>
-          </a:prstGeom>
-          <a:noFill xmlns:a="http://schemas.openxmlformats.org/drawingml/2006/main"/>
-          <a:ln xmlns:a="http://schemas.openxmlformats.org/drawingml/2006/main" w="0">
-            <a:noFill/>
-          </a:ln>
-        </p:spPr>
-        <p:txBody>
-          <a:bodyPr xmlns:a="http://schemas.openxmlformats.org/drawingml/2006/main">
-            <a:noAutofit/>
-          </a:bodyPr>
-          <a:lstStyle xmlns:a="http://schemas.openxmlformats.org/drawingml/2006/main"/>
-          <a:p xmlns:a="http://schemas.openxmlformats.org/drawingml/2006/main">
+          <a:prstGeom prst="rect">
+            <a:avLst/>
+          </a:prstGeom>
+          <a:noFill/>
+          <a:ln w="0">
+            <a:noFill/>
+          </a:ln>
+        </p:spPr>
+        <p:txBody>
+          <a:bodyPr>
+            <a:noAutofit/>
+          </a:bodyPr>
+          <a:lstStyle/>
+          <a:p>
             <a:pPr>
               <a:defRPr sz="2025" b="1">
                 <a:solidFill>
@@ -7248,36 +7248,36 @@
       <p:sp>
         <p:nvSpPr>
           <p:cNvPr id="5" name="">
-            <a:extLst xmlns:a="http://schemas.openxmlformats.org/drawingml/2006/main">
-              <a:ext uri="{FF2B5EF4-FFF2-40B4-BE49-F238E27FC236}">
-                <a16:creationId xmlns:a16="http://schemas.microsoft.com/office/drawing/2014/main" id="{4FABCFF2-4A7D-42F2-B4EF-E1777552D5B3}"/>
-              </a:ext>
-            </a:extLst>
-          </p:cNvPr>
-          <p:cNvSpPr>
-            <a:spLocks xmlns:a="http://schemas.openxmlformats.org/drawingml/2006/main" noGrp="1"/>
-          </p:cNvSpPr>
-          <p:nvPr/>
-        </p:nvSpPr>
-        <p:spPr>
-          <a:xfrm xmlns:a="http://schemas.openxmlformats.org/drawingml/2006/main">
+            <a:extLst>
+              <a:ext uri="{FF2B5EF4-FFF2-40B4-BE49-F238E27FC236}">
+                <ns2:creationId id="{4FABCFF2-4A7D-42F2-B4EF-E1777552D5B3}"/>
+              </a:ext>
+            </a:extLst>
+          </p:cNvPr>
+          <p:cNvSpPr>
+            <a:spLocks noGrp="1"/>
+          </p:cNvSpPr>
+          <p:nvPr/>
+        </p:nvSpPr>
+        <p:spPr>
+          <a:xfrm>
             <a:off x="742950" y="2733675"/>
             <a:ext cx="10668000" cy="476250"/>
           </a:xfrm>
-          <a:prstGeom xmlns:a="http://schemas.openxmlformats.org/drawingml/2006/main" prst="rect">
-            <a:avLst/>
-          </a:prstGeom>
-          <a:noFill xmlns:a="http://schemas.openxmlformats.org/drawingml/2006/main"/>
-          <a:ln xmlns:a="http://schemas.openxmlformats.org/drawingml/2006/main" w="0">
-            <a:noFill/>
-          </a:ln>
-        </p:spPr>
-        <p:txBody>
-          <a:bodyPr xmlns:a="http://schemas.openxmlformats.org/drawingml/2006/main">
-            <a:noAutofit/>
-          </a:bodyPr>
-          <a:lstStyle xmlns:a="http://schemas.openxmlformats.org/drawingml/2006/main"/>
-          <a:p xmlns:a="http://schemas.openxmlformats.org/drawingml/2006/main">
+          <a:prstGeom prst="rect">
+            <a:avLst/>
+          </a:prstGeom>
+          <a:noFill/>
+          <a:ln w="0">
+            <a:noFill/>
+          </a:ln>
+        </p:spPr>
+        <p:txBody>
+          <a:bodyPr>
+            <a:noAutofit/>
+          </a:bodyPr>
+          <a:lstStyle/>
+          <a:p>
             <a:pPr>
               <a:defRPr sz="1800" b="0">
                 <a:solidFill>
@@ -7305,36 +7305,36 @@
       <p:sp>
         <p:nvSpPr>
           <p:cNvPr id="6" name="">
-            <a:extLst xmlns:a="http://schemas.openxmlformats.org/drawingml/2006/main">
-              <a:ext uri="{FF2B5EF4-FFF2-40B4-BE49-F238E27FC236}">
-                <a16:creationId xmlns:a16="http://schemas.microsoft.com/office/drawing/2014/main" id="{D5F3B13A-835F-4E48-8966-F02A4AA7D9ED}"/>
-              </a:ext>
-            </a:extLst>
-          </p:cNvPr>
-          <p:cNvSpPr>
-            <a:spLocks xmlns:a="http://schemas.openxmlformats.org/drawingml/2006/main" noGrp="1"/>
-          </p:cNvSpPr>
-          <p:nvPr/>
-        </p:nvSpPr>
-        <p:spPr>
-          <a:xfrm xmlns:a="http://schemas.openxmlformats.org/drawingml/2006/main">
+            <a:extLst>
+              <a:ext uri="{FF2B5EF4-FFF2-40B4-BE49-F238E27FC236}">
+                <ns2:creationId id="{D5F3B13A-835F-4E48-8966-F02A4AA7D9ED}"/>
+              </a:ext>
+            </a:extLst>
+          </p:cNvPr>
+          <p:cNvSpPr>
+            <a:spLocks noGrp="1"/>
+          </p:cNvSpPr>
+          <p:nvPr/>
+        </p:nvSpPr>
+        <p:spPr>
+          <a:xfrm>
             <a:off x="742950" y="3286125"/>
             <a:ext cx="10668000" cy="323850"/>
           </a:xfrm>
-          <a:prstGeom xmlns:a="http://schemas.openxmlformats.org/drawingml/2006/main" prst="rect">
-            <a:avLst/>
-          </a:prstGeom>
-          <a:noFill xmlns:a="http://schemas.openxmlformats.org/drawingml/2006/main"/>
-          <a:ln xmlns:a="http://schemas.openxmlformats.org/drawingml/2006/main" w="0">
-            <a:noFill/>
-          </a:ln>
-        </p:spPr>
-        <p:txBody>
-          <a:bodyPr xmlns:a="http://schemas.openxmlformats.org/drawingml/2006/main">
-            <a:noAutofit/>
-          </a:bodyPr>
-          <a:lstStyle xmlns:a="http://schemas.openxmlformats.org/drawingml/2006/main"/>
-          <a:p xmlns:a="http://schemas.openxmlformats.org/drawingml/2006/main">
+          <a:prstGeom prst="rect">
+            <a:avLst/>
+          </a:prstGeom>
+          <a:noFill/>
+          <a:ln w="0">
+            <a:noFill/>
+          </a:ln>
+        </p:spPr>
+        <p:txBody>
+          <a:bodyPr>
+            <a:noAutofit/>
+          </a:bodyPr>
+          <a:lstStyle/>
+          <a:p>
             <a:pPr>
               <a:defRPr sz="2025" b="1">
                 <a:solidFill>
@@ -7362,36 +7362,36 @@
       <p:sp>
         <p:nvSpPr>
           <p:cNvPr id="7" name="">
-            <a:extLst xmlns:a="http://schemas.openxmlformats.org/drawingml/2006/main">
-              <a:ext uri="{FF2B5EF4-FFF2-40B4-BE49-F238E27FC236}">
-                <a16:creationId xmlns:a16="http://schemas.microsoft.com/office/drawing/2014/main" id="{EF731E26-2DE8-447A-BFF6-629021393AF0}"/>
-              </a:ext>
-            </a:extLst>
-          </p:cNvPr>
-          <p:cNvSpPr>
-            <a:spLocks xmlns:a="http://schemas.openxmlformats.org/drawingml/2006/main" noGrp="1"/>
-          </p:cNvSpPr>
-          <p:nvPr/>
-        </p:nvSpPr>
-        <p:spPr>
-          <a:xfrm xmlns:a="http://schemas.openxmlformats.org/drawingml/2006/main">
+            <a:extLst>
+              <a:ext uri="{FF2B5EF4-FFF2-40B4-BE49-F238E27FC236}">
+                <ns2:creationId id="{EF731E26-2DE8-447A-BFF6-629021393AF0}"/>
+              </a:ext>
+            </a:extLst>
+          </p:cNvPr>
+          <p:cNvSpPr>
+            <a:spLocks noGrp="1"/>
+          </p:cNvSpPr>
+          <p:nvPr/>
+        </p:nvSpPr>
+        <p:spPr>
+          <a:xfrm>
             <a:off x="742950" y="3657600"/>
             <a:ext cx="10668000" cy="476250"/>
           </a:xfrm>
-          <a:prstGeom xmlns:a="http://schemas.openxmlformats.org/drawingml/2006/main" prst="rect">
-            <a:avLst/>
-          </a:prstGeom>
-          <a:noFill xmlns:a="http://schemas.openxmlformats.org/drawingml/2006/main"/>
-          <a:ln xmlns:a="http://schemas.openxmlformats.org/drawingml/2006/main" w="0">
-            <a:noFill/>
-          </a:ln>
-        </p:spPr>
-        <p:txBody>
-          <a:bodyPr xmlns:a="http://schemas.openxmlformats.org/drawingml/2006/main">
-            <a:noAutofit/>
-          </a:bodyPr>
-          <a:lstStyle xmlns:a="http://schemas.openxmlformats.org/drawingml/2006/main"/>
-          <a:p xmlns:a="http://schemas.openxmlformats.org/drawingml/2006/main">
+          <a:prstGeom prst="rect">
+            <a:avLst/>
+          </a:prstGeom>
+          <a:noFill/>
+          <a:ln w="0">
+            <a:noFill/>
+          </a:ln>
+        </p:spPr>
+        <p:txBody>
+          <a:bodyPr>
+            <a:noAutofit/>
+          </a:bodyPr>
+          <a:lstStyle/>
+          <a:p>
             <a:pPr>
               <a:defRPr sz="1800" b="0">
                 <a:solidFill>
@@ -7419,36 +7419,36 @@
       <p:sp>
         <p:nvSpPr>
           <p:cNvPr id="8" name="">
-            <a:extLst xmlns:a="http://schemas.openxmlformats.org/drawingml/2006/main">
-              <a:ext uri="{FF2B5EF4-FFF2-40B4-BE49-F238E27FC236}">
-                <a16:creationId xmlns:a16="http://schemas.microsoft.com/office/drawing/2014/main" id="{A6CBB4DB-EA52-45F0-8B0E-B6B9D0C5013A}"/>
-              </a:ext>
-            </a:extLst>
-          </p:cNvPr>
-          <p:cNvSpPr>
-            <a:spLocks xmlns:a="http://schemas.openxmlformats.org/drawingml/2006/main" noGrp="1"/>
-          </p:cNvSpPr>
-          <p:nvPr/>
-        </p:nvSpPr>
-        <p:spPr>
-          <a:xfrm xmlns:a="http://schemas.openxmlformats.org/drawingml/2006/main">
+            <a:extLst>
+              <a:ext uri="{FF2B5EF4-FFF2-40B4-BE49-F238E27FC236}">
+                <ns2:creationId id="{A6CBB4DB-EA52-45F0-8B0E-B6B9D0C5013A}"/>
+              </a:ext>
+            </a:extLst>
+          </p:cNvPr>
+          <p:cNvSpPr>
+            <a:spLocks noGrp="1"/>
+          </p:cNvSpPr>
+          <p:nvPr/>
+        </p:nvSpPr>
+        <p:spPr>
+          <a:xfrm>
             <a:off x="742950" y="4210050"/>
             <a:ext cx="10668000" cy="323850"/>
           </a:xfrm>
-          <a:prstGeom xmlns:a="http://schemas.openxmlformats.org/drawingml/2006/main" prst="rect">
-            <a:avLst/>
-          </a:prstGeom>
-          <a:noFill xmlns:a="http://schemas.openxmlformats.org/drawingml/2006/main"/>
-          <a:ln xmlns:a="http://schemas.openxmlformats.org/drawingml/2006/main" w="0">
-            <a:noFill/>
-          </a:ln>
-        </p:spPr>
-        <p:txBody>
-          <a:bodyPr xmlns:a="http://schemas.openxmlformats.org/drawingml/2006/main">
-            <a:noAutofit/>
-          </a:bodyPr>
-          <a:lstStyle xmlns:a="http://schemas.openxmlformats.org/drawingml/2006/main"/>
-          <a:p xmlns:a="http://schemas.openxmlformats.org/drawingml/2006/main">
+          <a:prstGeom prst="rect">
+            <a:avLst/>
+          </a:prstGeom>
+          <a:noFill/>
+          <a:ln w="0">
+            <a:noFill/>
+          </a:ln>
+        </p:spPr>
+        <p:txBody>
+          <a:bodyPr>
+            <a:noAutofit/>
+          </a:bodyPr>
+          <a:lstStyle/>
+          <a:p>
             <a:pPr>
               <a:defRPr sz="2025" b="1">
                 <a:solidFill>
@@ -7476,36 +7476,36 @@
       <p:sp>
         <p:nvSpPr>
           <p:cNvPr id="9" name="">
-            <a:extLst xmlns:a="http://schemas.openxmlformats.org/drawingml/2006/main">
-              <a:ext uri="{FF2B5EF4-FFF2-40B4-BE49-F238E27FC236}">
-                <a16:creationId xmlns:a16="http://schemas.microsoft.com/office/drawing/2014/main" id="{F9C658D6-77C2-4F75-BAA5-5966BC72BB51}"/>
-              </a:ext>
-            </a:extLst>
-          </p:cNvPr>
-          <p:cNvSpPr>
-            <a:spLocks xmlns:a="http://schemas.openxmlformats.org/drawingml/2006/main" noGrp="1"/>
-          </p:cNvSpPr>
-          <p:nvPr/>
-        </p:nvSpPr>
-        <p:spPr>
-          <a:xfrm xmlns:a="http://schemas.openxmlformats.org/drawingml/2006/main">
+            <a:extLst>
+              <a:ext uri="{FF2B5EF4-FFF2-40B4-BE49-F238E27FC236}">
+                <ns2:creationId id="{F9C658D6-77C2-4F75-BAA5-5966BC72BB51}"/>
+              </a:ext>
+            </a:extLst>
+          </p:cNvPr>
+          <p:cNvSpPr>
+            <a:spLocks noGrp="1"/>
+          </p:cNvSpPr>
+          <p:nvPr/>
+        </p:nvSpPr>
+        <p:spPr>
+          <a:xfrm>
             <a:off x="742950" y="4581525"/>
             <a:ext cx="10668000" cy="476250"/>
           </a:xfrm>
-          <a:prstGeom xmlns:a="http://schemas.openxmlformats.org/drawingml/2006/main" prst="rect">
-            <a:avLst/>
-          </a:prstGeom>
-          <a:noFill xmlns:a="http://schemas.openxmlformats.org/drawingml/2006/main"/>
-          <a:ln xmlns:a="http://schemas.openxmlformats.org/drawingml/2006/main" w="0">
-            <a:noFill/>
-          </a:ln>
-        </p:spPr>
-        <p:txBody>
-          <a:bodyPr xmlns:a="http://schemas.openxmlformats.org/drawingml/2006/main">
-            <a:noAutofit/>
-          </a:bodyPr>
-          <a:lstStyle xmlns:a="http://schemas.openxmlformats.org/drawingml/2006/main"/>
-          <a:p xmlns:a="http://schemas.openxmlformats.org/drawingml/2006/main">
+          <a:prstGeom prst="rect">
+            <a:avLst/>
+          </a:prstGeom>
+          <a:noFill/>
+          <a:ln w="0">
+            <a:noFill/>
+          </a:ln>
+        </p:spPr>
+        <p:txBody>
+          <a:bodyPr>
+            <a:noAutofit/>
+          </a:bodyPr>
+          <a:lstStyle/>
+          <a:p>
             <a:pPr>
               <a:defRPr sz="1800" b="0">
                 <a:solidFill>
@@ -7533,37 +7533,38 @@
       <p:sp>
         <p:nvSpPr>
           <p:cNvPr id="10" name="">
-            <a:extLst xmlns:a="http://schemas.openxmlformats.org/drawingml/2006/main">
-              <a:ext uri="{FF2B5EF4-FFF2-40B4-BE49-F238E27FC236}">
-                <a16:creationId xmlns:a16="http://schemas.microsoft.com/office/drawing/2014/main" id="{B6F23DB5-B16E-423D-AC48-41B1330510E2}"/>
-              </a:ext>
-            </a:extLst>
-          </p:cNvPr>
-          <p:cNvSpPr>
-            <a:spLocks xmlns:a="http://schemas.openxmlformats.org/drawingml/2006/main" noGrp="1"/>
-          </p:cNvSpPr>
-          <p:nvPr/>
-        </p:nvSpPr>
-        <p:spPr>
-          <a:xfrm xmlns:a="http://schemas.openxmlformats.org/drawingml/2006/main">
+            <a:extLst>
+              <a:ext uri="{FF2B5EF4-FFF2-40B4-BE49-F238E27FC236}">
+                <ns2:creationId id="{B6F23DB5-B16E-423D-AC48-41B1330510E2}"/>
+              </a:ext>
+            </a:extLst>
+          </p:cNvPr>
+          <p:cNvSpPr>
+            <a:spLocks noGrp="1"/>
+          </p:cNvSpPr>
+          <p:nvPr/>
+        </p:nvSpPr>
+        <p:spPr>
+          <a:xfrm>
             <a:off x="742950" y="5133975"/>
             <a:ext cx="10668000" cy="323850"/>
           </a:xfrm>
-          <a:prstGeom xmlns:a="http://schemas.openxmlformats.org/drawingml/2006/main" prst="rect">
-            <a:avLst/>
-          </a:prstGeom>
-          <a:noFill xmlns:a="http://schemas.openxmlformats.org/drawingml/2006/main"/>
-          <a:ln xmlns:a="http://schemas.openxmlformats.org/drawingml/2006/main" w="0">
-            <a:noFill/>
-          </a:ln>
-        </p:spPr>
-        <p:txBody>
-          <a:bodyPr xmlns:a="http://schemas.openxmlformats.org/drawingml/2006/main">
-            <a:noAutofit/>
-          </a:bodyPr>
-          <a:lstStyle xmlns:a="http://schemas.openxmlformats.org/drawingml/2006/main"/>
-          <a:p xmlns:a="http://schemas.openxmlformats.org/drawingml/2006/main">
-            <a:pPr>
+          <a:prstGeom prst="rect">
+            <a:avLst/>
+          </a:prstGeom>
+          <a:noFill/>
+          <a:ln w="0">
+            <a:noFill/>
+          </a:ln>
+        </p:spPr>
+        <p:txBody>
+          <a:bodyPr>
+            <a:noAutofit/>
+          </a:bodyPr>
+          <a:lstStyle/>
+          <a:p>
+            <a:pPr>
+              <a:buNone/>
               <a:defRPr sz="2025" b="1">
                 <a:solidFill>
                   <a:srgbClr val="176CAD"/>
@@ -7582,7 +7583,7 @@
                 <a:ea typeface="Helvetica Neue"/>
                 <a:cs typeface="Helvetica Neue"/>
               </a:rPr>
-              <a:t>maximumReadingGapSeconds = null</a:t>
+              <a:t>longSilenceBoundarySeconds = 10</a:t>
             </a:r>
           </a:p>
         </p:txBody>
@@ -7590,37 +7591,38 @@
       <p:sp>
         <p:nvSpPr>
           <p:cNvPr id="11" name="">
-            <a:extLst xmlns:a="http://schemas.openxmlformats.org/drawingml/2006/main">
-              <a:ext uri="{FF2B5EF4-FFF2-40B4-BE49-F238E27FC236}">
-                <a16:creationId xmlns:a16="http://schemas.microsoft.com/office/drawing/2014/main" id="{DFCAB9E3-F28C-44F5-83DC-7A22C5054AD1}"/>
-              </a:ext>
-            </a:extLst>
-          </p:cNvPr>
-          <p:cNvSpPr>
-            <a:spLocks xmlns:a="http://schemas.openxmlformats.org/drawingml/2006/main" noGrp="1"/>
-          </p:cNvSpPr>
-          <p:nvPr/>
-        </p:nvSpPr>
-        <p:spPr>
-          <a:xfrm xmlns:a="http://schemas.openxmlformats.org/drawingml/2006/main">
+            <a:extLst>
+              <a:ext uri="{FF2B5EF4-FFF2-40B4-BE49-F238E27FC236}">
+                <ns2:creationId id="{DFCAB9E3-F28C-44F5-83DC-7A22C5054AD1}"/>
+              </a:ext>
+            </a:extLst>
+          </p:cNvPr>
+          <p:cNvSpPr>
+            <a:spLocks noGrp="1"/>
+          </p:cNvSpPr>
+          <p:nvPr/>
+        </p:nvSpPr>
+        <p:spPr>
+          <a:xfrm>
             <a:off x="742950" y="5505450"/>
             <a:ext cx="10668000" cy="476250"/>
           </a:xfrm>
-          <a:prstGeom xmlns:a="http://schemas.openxmlformats.org/drawingml/2006/main" prst="rect">
-            <a:avLst/>
-          </a:prstGeom>
-          <a:noFill xmlns:a="http://schemas.openxmlformats.org/drawingml/2006/main"/>
-          <a:ln xmlns:a="http://schemas.openxmlformats.org/drawingml/2006/main" w="0">
-            <a:noFill/>
-          </a:ln>
-        </p:spPr>
-        <p:txBody>
-          <a:bodyPr xmlns:a="http://schemas.openxmlformats.org/drawingml/2006/main">
-            <a:noAutofit/>
-          </a:bodyPr>
-          <a:lstStyle xmlns:a="http://schemas.openxmlformats.org/drawingml/2006/main"/>
-          <a:p xmlns:a="http://schemas.openxmlformats.org/drawingml/2006/main">
-            <a:pPr>
+          <a:prstGeom prst="rect">
+            <a:avLst/>
+          </a:prstGeom>
+          <a:noFill/>
+          <a:ln w="0">
+            <a:noFill/>
+          </a:ln>
+        </p:spPr>
+        <p:txBody>
+          <a:bodyPr>
+            <a:noAutofit/>
+          </a:bodyPr>
+          <a:lstStyle/>
+          <a:p>
+            <a:pPr>
+              <a:buNone/>
               <a:defRPr sz="1800" b="0">
                 <a:solidFill>
                   <a:srgbClr val="142735"/>
@@ -7639,7 +7641,31 @@
                 <a:ea typeface="Helvetica Neue"/>
                 <a:cs typeface="Helvetica Neue"/>
               </a:rPr>
-              <a:t>Disables the silence cutoff. Same-speaker speech stays together across a pause.</a:t>
+              <a:t>Gap ≥ 10 s starts a new turn, even for S1 → S1.</a:t>
+            </a:r>
+          </a:p>
+          <a:p>
+            <a:pPr>
+              <a:buNone/>
+              <a:defRPr sz="1800" b="0">
+                <a:solidFill>
+                  <a:srgbClr val="142735"/>
+                </a:solidFill>
+                <a:latin typeface="Helvetica Neue"/>
+                <a:ea typeface="Helvetica Neue"/>
+                <a:cs typeface="Helvetica Neue"/>
+              </a:defRPr>
+            </a:pPr>
+            <a:r>
+              <a:rPr sz="1800" b="0">
+                <a:solidFill>
+                  <a:srgbClr val="142735"/>
+                </a:solidFill>
+                <a:latin typeface="Helvetica Neue"/>
+                <a:ea typeface="Helvetica Neue"/>
+                <a:cs typeface="Helvetica Neue"/>
+              </a:rPr>
+              <a:t>maximumReadingGapSeconds = null adds no stricter gap cut.</a:t>
             </a:r>
           </a:p>
         </p:txBody>
@@ -7647,37 +7673,38 @@
       <p:sp>
         <p:nvSpPr>
           <p:cNvPr id="12" name="">
-            <a:extLst xmlns:a="http://schemas.openxmlformats.org/drawingml/2006/main">
-              <a:ext uri="{FF2B5EF4-FFF2-40B4-BE49-F238E27FC236}">
-                <a16:creationId xmlns:a16="http://schemas.microsoft.com/office/drawing/2014/main" id="{6CB7C364-1192-4B3C-846B-D5DB82C86424}"/>
-              </a:ext>
-            </a:extLst>
-          </p:cNvPr>
-          <p:cNvSpPr>
-            <a:spLocks xmlns:a="http://schemas.openxmlformats.org/drawingml/2006/main" noGrp="1"/>
-          </p:cNvSpPr>
-          <p:nvPr/>
-        </p:nvSpPr>
-        <p:spPr>
-          <a:xfrm xmlns:a="http://schemas.openxmlformats.org/drawingml/2006/main">
+            <a:extLst>
+              <a:ext uri="{FF2B5EF4-FFF2-40B4-BE49-F238E27FC236}">
+                <ns2:creationId id="{6CB7C364-1192-4B3C-846B-D5DB82C86424}"/>
+              </a:ext>
+            </a:extLst>
+          </p:cNvPr>
+          <p:cNvSpPr>
+            <a:spLocks noGrp="1"/>
+          </p:cNvSpPr>
+          <p:nvPr/>
+        </p:nvSpPr>
+        <p:spPr>
+          <a:xfrm>
             <a:off x="742950" y="6305550"/>
             <a:ext cx="10668000" cy="361950"/>
           </a:xfrm>
-          <a:prstGeom xmlns:a="http://schemas.openxmlformats.org/drawingml/2006/main" prst="rect">
-            <a:avLst/>
-          </a:prstGeom>
-          <a:noFill xmlns:a="http://schemas.openxmlformats.org/drawingml/2006/main"/>
-          <a:ln xmlns:a="http://schemas.openxmlformats.org/drawingml/2006/main" w="0">
-            <a:noFill/>
-          </a:ln>
-        </p:spPr>
-        <p:txBody>
-          <a:bodyPr xmlns:a="http://schemas.openxmlformats.org/drawingml/2006/main">
-            <a:noAutofit/>
-          </a:bodyPr>
-          <a:lstStyle xmlns:a="http://schemas.openxmlformats.org/drawingml/2006/main"/>
-          <a:p xmlns:a="http://schemas.openxmlformats.org/drawingml/2006/main">
-            <a:pPr>
+          <a:prstGeom prst="rect">
+            <a:avLst/>
+          </a:prstGeom>
+          <a:noFill/>
+          <a:ln w="0">
+            <a:noFill/>
+          </a:ln>
+        </p:spPr>
+        <p:txBody>
+          <a:bodyPr>
+            <a:noAutofit/>
+          </a:bodyPr>
+          <a:lstStyle/>
+          <a:p>
+            <a:pPr>
+              <a:buNone/>
               <a:defRPr sz="1575" b="0">
                 <a:solidFill>
                   <a:srgbClr val="485C74"/>
@@ -7696,7 +7723,7 @@
                 <a:ea typeface="Helvetica Neue"/>
                 <a:cs typeface="Helvetica Neue"/>
               </a:rPr>
-              <a:t>Sejm check: 32 blocks became 4 turns. All 802 source parts survived. Meaning checks remain open.</a:t>
+              <a:t>Sejm pause: 33.28 s. Same S1, new segment. Source words and corrections remain saved.</a:t>
             </a:r>
           </a:p>
         </p:txBody>
@@ -7704,7 +7731,7 @@
     </p:spTree>
     <p:extLst>
       <p:ext uri="{BB962C8B-B14F-4D97-AF65-F5344CB8AC3E}">
-        <p14:creationId xmlns:p14="http://schemas.microsoft.com/office/powerpoint/2010/main" val="511128086"/>
+        <ns3:creationId val="511128086"/>
       </p:ext>
     </p:extLst>
   </p:cSld>
@@ -7712,11 +7739,11 @@
 </file>
 
 <file path=ppt/slides/slide19.xml><?xml version="1.0" encoding="utf-8"?>
-<p:sld xmlns:p="http://schemas.openxmlformats.org/presentationml/2006/main">
+<p:sld xmlns:a="http://schemas.openxmlformats.org/drawingml/2006/main" xmlns:ns2="http://schemas.microsoft.com/office/drawing/2014/main" xmlns:ns3="http://schemas.microsoft.com/office/powerpoint/2010/main" xmlns:p="http://schemas.openxmlformats.org/presentationml/2006/main">
   <p:cSld>
     <p:bg>
       <p:bgPr>
-        <a:solidFill xmlns:a="http://schemas.openxmlformats.org/drawingml/2006/main">
+        <a:solidFill>
           <a:srgbClr val="FFFFFF"/>
         </a:solidFill>
       </p:bgPr>
@@ -7728,41 +7755,41 @@
         <p:nvPr/>
       </p:nvGrpSpPr>
       <p:grpSpPr>
-        <a:xfrm xmlns:a="http://schemas.openxmlformats.org/drawingml/2006/main"/>
+        <a:xfrm/>
       </p:grpSpPr>
       <p:sp>
         <p:nvSpPr>
           <p:cNvPr id="13" name="">
-            <a:extLst xmlns:a="http://schemas.openxmlformats.org/drawingml/2006/main">
-              <a:ext uri="{FF2B5EF4-FFF2-40B4-BE49-F238E27FC236}">
-                <a16:creationId xmlns:a16="http://schemas.microsoft.com/office/drawing/2014/main" id="{14510CF3-804E-4C93-9443-197239044E8D}"/>
-              </a:ext>
-            </a:extLst>
-          </p:cNvPr>
-          <p:cNvSpPr>
-            <a:spLocks xmlns:a="http://schemas.openxmlformats.org/drawingml/2006/main" noGrp="1"/>
-          </p:cNvSpPr>
-          <p:nvPr/>
-        </p:nvSpPr>
-        <p:spPr>
-          <a:xfrm xmlns:a="http://schemas.openxmlformats.org/drawingml/2006/main">
+            <a:extLst>
+              <a:ext uri="{FF2B5EF4-FFF2-40B4-BE49-F238E27FC236}">
+                <ns2:creationId id="{14510CF3-804E-4C93-9443-197239044E8D}"/>
+              </a:ext>
+            </a:extLst>
+          </p:cNvPr>
+          <p:cNvSpPr>
+            <a:spLocks noGrp="1"/>
+          </p:cNvSpPr>
+          <p:nvPr/>
+        </p:nvSpPr>
+        <p:spPr>
+          <a:xfrm>
             <a:off x="742950" y="447675"/>
             <a:ext cx="10668000" cy="742950"/>
           </a:xfrm>
-          <a:prstGeom xmlns:a="http://schemas.openxmlformats.org/drawingml/2006/main" prst="rect">
-            <a:avLst/>
-          </a:prstGeom>
-          <a:noFill xmlns:a="http://schemas.openxmlformats.org/drawingml/2006/main"/>
-          <a:ln xmlns:a="http://schemas.openxmlformats.org/drawingml/2006/main" w="0">
-            <a:noFill/>
-          </a:ln>
-        </p:spPr>
-        <p:txBody>
-          <a:bodyPr xmlns:a="http://schemas.openxmlformats.org/drawingml/2006/main">
-            <a:noAutofit/>
-          </a:bodyPr>
-          <a:lstStyle xmlns:a="http://schemas.openxmlformats.org/drawingml/2006/main"/>
-          <a:p xmlns:a="http://schemas.openxmlformats.org/drawingml/2006/main">
+          <a:prstGeom prst="rect">
+            <a:avLst/>
+          </a:prstGeom>
+          <a:noFill/>
+          <a:ln w="0">
+            <a:noFill/>
+          </a:ln>
+        </p:spPr>
+        <p:txBody>
+          <a:bodyPr>
+            <a:noAutofit/>
+          </a:bodyPr>
+          <a:lstStyle/>
+          <a:p>
             <a:pPr>
               <a:defRPr sz="3000" b="1">
                 <a:solidFill>
@@ -7790,36 +7817,36 @@
       <p:sp>
         <p:nvSpPr>
           <p:cNvPr id="2" name="">
-            <a:extLst xmlns:a="http://schemas.openxmlformats.org/drawingml/2006/main">
-              <a:ext uri="{FF2B5EF4-FFF2-40B4-BE49-F238E27FC236}">
-                <a16:creationId xmlns:a16="http://schemas.microsoft.com/office/drawing/2014/main" id="{F4914359-965B-45BB-B5EE-F3EA3D812F42}"/>
-              </a:ext>
-            </a:extLst>
-          </p:cNvPr>
-          <p:cNvSpPr>
-            <a:spLocks xmlns:a="http://schemas.openxmlformats.org/drawingml/2006/main" noGrp="1"/>
-          </p:cNvSpPr>
-          <p:nvPr/>
-        </p:nvSpPr>
-        <p:spPr>
-          <a:xfrm xmlns:a="http://schemas.openxmlformats.org/drawingml/2006/main">
+            <a:extLst>
+              <a:ext uri="{FF2B5EF4-FFF2-40B4-BE49-F238E27FC236}">
+                <ns2:creationId id="{F4914359-965B-45BB-B5EE-F3EA3D812F42}"/>
+              </a:ext>
+            </a:extLst>
+          </p:cNvPr>
+          <p:cNvSpPr>
+            <a:spLocks noGrp="1"/>
+          </p:cNvSpPr>
+          <p:nvPr/>
+        </p:nvSpPr>
+        <p:spPr>
+          <a:xfrm>
             <a:off x="742950" y="1438275"/>
             <a:ext cx="10668000" cy="352425"/>
           </a:xfrm>
-          <a:prstGeom xmlns:a="http://schemas.openxmlformats.org/drawingml/2006/main" prst="rect">
-            <a:avLst/>
-          </a:prstGeom>
-          <a:noFill xmlns:a="http://schemas.openxmlformats.org/drawingml/2006/main"/>
-          <a:ln xmlns:a="http://schemas.openxmlformats.org/drawingml/2006/main" w="0">
-            <a:noFill/>
-          </a:ln>
-        </p:spPr>
-        <p:txBody>
-          <a:bodyPr xmlns:a="http://schemas.openxmlformats.org/drawingml/2006/main">
-            <a:noAutofit/>
-          </a:bodyPr>
-          <a:lstStyle xmlns:a="http://schemas.openxmlformats.org/drawingml/2006/main"/>
-          <a:p xmlns:a="http://schemas.openxmlformats.org/drawingml/2006/main">
+          <a:prstGeom prst="rect">
+            <a:avLst/>
+          </a:prstGeom>
+          <a:noFill/>
+          <a:ln w="0">
+            <a:noFill/>
+          </a:ln>
+        </p:spPr>
+        <p:txBody>
+          <a:bodyPr>
+            <a:noAutofit/>
+          </a:bodyPr>
+          <a:lstStyle/>
+          <a:p>
             <a:pPr>
               <a:defRPr sz="2100" b="1">
                 <a:solidFill>
@@ -7847,36 +7874,36 @@
       <p:sp>
         <p:nvSpPr>
           <p:cNvPr id="3" name="">
-            <a:extLst xmlns:a="http://schemas.openxmlformats.org/drawingml/2006/main">
-              <a:ext uri="{FF2B5EF4-FFF2-40B4-BE49-F238E27FC236}">
-                <a16:creationId xmlns:a16="http://schemas.microsoft.com/office/drawing/2014/main" id="{92B03857-CEB4-451D-9E57-5F211BDBE82E}"/>
-              </a:ext>
-            </a:extLst>
-          </p:cNvPr>
-          <p:cNvSpPr>
-            <a:spLocks xmlns:a="http://schemas.openxmlformats.org/drawingml/2006/main" noGrp="1"/>
-          </p:cNvSpPr>
-          <p:nvPr/>
-        </p:nvSpPr>
-        <p:spPr>
-          <a:xfrm xmlns:a="http://schemas.openxmlformats.org/drawingml/2006/main">
+            <a:extLst>
+              <a:ext uri="{FF2B5EF4-FFF2-40B4-BE49-F238E27FC236}">
+                <ns2:creationId id="{92B03857-CEB4-451D-9E57-5F211BDBE82E}"/>
+              </a:ext>
+            </a:extLst>
+          </p:cNvPr>
+          <p:cNvSpPr>
+            <a:spLocks noGrp="1"/>
+          </p:cNvSpPr>
+          <p:nvPr/>
+        </p:nvSpPr>
+        <p:spPr>
+          <a:xfrm>
             <a:off x="742950" y="1819275"/>
             <a:ext cx="10668000" cy="581025"/>
           </a:xfrm>
-          <a:prstGeom xmlns:a="http://schemas.openxmlformats.org/drawingml/2006/main" prst="rect">
-            <a:avLst/>
-          </a:prstGeom>
-          <a:noFill xmlns:a="http://schemas.openxmlformats.org/drawingml/2006/main"/>
-          <a:ln xmlns:a="http://schemas.openxmlformats.org/drawingml/2006/main" w="0">
-            <a:noFill/>
-          </a:ln>
-        </p:spPr>
-        <p:txBody>
-          <a:bodyPr xmlns:a="http://schemas.openxmlformats.org/drawingml/2006/main">
-            <a:noAutofit/>
-          </a:bodyPr>
-          <a:lstStyle xmlns:a="http://schemas.openxmlformats.org/drawingml/2006/main"/>
-          <a:p xmlns:a="http://schemas.openxmlformats.org/drawingml/2006/main">
+          <a:prstGeom prst="rect">
+            <a:avLst/>
+          </a:prstGeom>
+          <a:noFill/>
+          <a:ln w="0">
+            <a:noFill/>
+          </a:ln>
+        </p:spPr>
+        <p:txBody>
+          <a:bodyPr>
+            <a:noAutofit/>
+          </a:bodyPr>
+          <a:lstStyle/>
+          <a:p>
             <a:pPr>
               <a:defRPr sz="1800" b="0">
                 <a:solidFill>
@@ -7904,36 +7931,36 @@
       <p:sp>
         <p:nvSpPr>
           <p:cNvPr id="4" name="">
-            <a:extLst xmlns:a="http://schemas.openxmlformats.org/drawingml/2006/main">
-              <a:ext uri="{FF2B5EF4-FFF2-40B4-BE49-F238E27FC236}">
-                <a16:creationId xmlns:a16="http://schemas.microsoft.com/office/drawing/2014/main" id="{F95620A2-5D50-4CBB-99A1-051716BD51EE}"/>
-              </a:ext>
-            </a:extLst>
-          </p:cNvPr>
-          <p:cNvSpPr>
-            <a:spLocks xmlns:a="http://schemas.openxmlformats.org/drawingml/2006/main" noGrp="1"/>
-          </p:cNvSpPr>
-          <p:nvPr/>
-        </p:nvSpPr>
-        <p:spPr>
-          <a:xfrm xmlns:a="http://schemas.openxmlformats.org/drawingml/2006/main">
+            <a:extLst>
+              <a:ext uri="{FF2B5EF4-FFF2-40B4-BE49-F238E27FC236}">
+                <ns2:creationId id="{F95620A2-5D50-4CBB-99A1-051716BD51EE}"/>
+              </a:ext>
+            </a:extLst>
+          </p:cNvPr>
+          <p:cNvSpPr>
+            <a:spLocks noGrp="1"/>
+          </p:cNvSpPr>
+          <p:nvPr/>
+        </p:nvSpPr>
+        <p:spPr>
+          <a:xfrm>
             <a:off x="742950" y="2352675"/>
             <a:ext cx="10668000" cy="352425"/>
           </a:xfrm>
-          <a:prstGeom xmlns:a="http://schemas.openxmlformats.org/drawingml/2006/main" prst="rect">
-            <a:avLst/>
-          </a:prstGeom>
-          <a:noFill xmlns:a="http://schemas.openxmlformats.org/drawingml/2006/main"/>
-          <a:ln xmlns:a="http://schemas.openxmlformats.org/drawingml/2006/main" w="0">
-            <a:noFill/>
-          </a:ln>
-        </p:spPr>
-        <p:txBody>
-          <a:bodyPr xmlns:a="http://schemas.openxmlformats.org/drawingml/2006/main">
-            <a:noAutofit/>
-          </a:bodyPr>
-          <a:lstStyle xmlns:a="http://schemas.openxmlformats.org/drawingml/2006/main"/>
-          <a:p xmlns:a="http://schemas.openxmlformats.org/drawingml/2006/main">
+          <a:prstGeom prst="rect">
+            <a:avLst/>
+          </a:prstGeom>
+          <a:noFill/>
+          <a:ln w="0">
+            <a:noFill/>
+          </a:ln>
+        </p:spPr>
+        <p:txBody>
+          <a:bodyPr>
+            <a:noAutofit/>
+          </a:bodyPr>
+          <a:lstStyle/>
+          <a:p>
             <a:pPr>
               <a:defRPr sz="2100" b="1">
                 <a:solidFill>
@@ -7961,36 +7988,36 @@
       <p:sp>
         <p:nvSpPr>
           <p:cNvPr id="5" name="">
-            <a:extLst xmlns:a="http://schemas.openxmlformats.org/drawingml/2006/main">
-              <a:ext uri="{FF2B5EF4-FFF2-40B4-BE49-F238E27FC236}">
-                <a16:creationId xmlns:a16="http://schemas.microsoft.com/office/drawing/2014/main" id="{D28D3141-BE30-4006-9EEB-807DD1773166}"/>
-              </a:ext>
-            </a:extLst>
-          </p:cNvPr>
-          <p:cNvSpPr>
-            <a:spLocks xmlns:a="http://schemas.openxmlformats.org/drawingml/2006/main" noGrp="1"/>
-          </p:cNvSpPr>
-          <p:nvPr/>
-        </p:nvSpPr>
-        <p:spPr>
-          <a:xfrm xmlns:a="http://schemas.openxmlformats.org/drawingml/2006/main">
+            <a:extLst>
+              <a:ext uri="{FF2B5EF4-FFF2-40B4-BE49-F238E27FC236}">
+                <ns2:creationId id="{D28D3141-BE30-4006-9EEB-807DD1773166}"/>
+              </a:ext>
+            </a:extLst>
+          </p:cNvPr>
+          <p:cNvSpPr>
+            <a:spLocks noGrp="1"/>
+          </p:cNvSpPr>
+          <p:nvPr/>
+        </p:nvSpPr>
+        <p:spPr>
+          <a:xfrm>
             <a:off x="742950" y="2733675"/>
             <a:ext cx="10668000" cy="581025"/>
           </a:xfrm>
-          <a:prstGeom xmlns:a="http://schemas.openxmlformats.org/drawingml/2006/main" prst="rect">
-            <a:avLst/>
-          </a:prstGeom>
-          <a:noFill xmlns:a="http://schemas.openxmlformats.org/drawingml/2006/main"/>
-          <a:ln xmlns:a="http://schemas.openxmlformats.org/drawingml/2006/main" w="0">
-            <a:noFill/>
-          </a:ln>
-        </p:spPr>
-        <p:txBody>
-          <a:bodyPr xmlns:a="http://schemas.openxmlformats.org/drawingml/2006/main">
-            <a:noAutofit/>
-          </a:bodyPr>
-          <a:lstStyle xmlns:a="http://schemas.openxmlformats.org/drawingml/2006/main"/>
-          <a:p xmlns:a="http://schemas.openxmlformats.org/drawingml/2006/main">
+          <a:prstGeom prst="rect">
+            <a:avLst/>
+          </a:prstGeom>
+          <a:noFill/>
+          <a:ln w="0">
+            <a:noFill/>
+          </a:ln>
+        </p:spPr>
+        <p:txBody>
+          <a:bodyPr>
+            <a:noAutofit/>
+          </a:bodyPr>
+          <a:lstStyle/>
+          <a:p>
             <a:pPr>
               <a:defRPr sz="1800" b="0">
                 <a:solidFill>
@@ -8018,36 +8045,36 @@
       <p:sp>
         <p:nvSpPr>
           <p:cNvPr id="6" name="">
-            <a:extLst xmlns:a="http://schemas.openxmlformats.org/drawingml/2006/main">
-              <a:ext uri="{FF2B5EF4-FFF2-40B4-BE49-F238E27FC236}">
-                <a16:creationId xmlns:a16="http://schemas.microsoft.com/office/drawing/2014/main" id="{5A4E1BC3-FA8B-4E6F-8B09-1D239C01A34E}"/>
-              </a:ext>
-            </a:extLst>
-          </p:cNvPr>
-          <p:cNvSpPr>
-            <a:spLocks xmlns:a="http://schemas.openxmlformats.org/drawingml/2006/main" noGrp="1"/>
-          </p:cNvSpPr>
-          <p:nvPr/>
-        </p:nvSpPr>
-        <p:spPr>
-          <a:xfrm xmlns:a="http://schemas.openxmlformats.org/drawingml/2006/main">
+            <a:extLst>
+              <a:ext uri="{FF2B5EF4-FFF2-40B4-BE49-F238E27FC236}">
+                <ns2:creationId id="{5A4E1BC3-FA8B-4E6F-8B09-1D239C01A34E}"/>
+              </a:ext>
+            </a:extLst>
+          </p:cNvPr>
+          <p:cNvSpPr>
+            <a:spLocks noGrp="1"/>
+          </p:cNvSpPr>
+          <p:nvPr/>
+        </p:nvSpPr>
+        <p:spPr>
+          <a:xfrm>
             <a:off x="742950" y="3267075"/>
             <a:ext cx="10668000" cy="352425"/>
           </a:xfrm>
-          <a:prstGeom xmlns:a="http://schemas.openxmlformats.org/drawingml/2006/main" prst="rect">
-            <a:avLst/>
-          </a:prstGeom>
-          <a:noFill xmlns:a="http://schemas.openxmlformats.org/drawingml/2006/main"/>
-          <a:ln xmlns:a="http://schemas.openxmlformats.org/drawingml/2006/main" w="0">
-            <a:noFill/>
-          </a:ln>
-        </p:spPr>
-        <p:txBody>
-          <a:bodyPr xmlns:a="http://schemas.openxmlformats.org/drawingml/2006/main">
-            <a:noAutofit/>
-          </a:bodyPr>
-          <a:lstStyle xmlns:a="http://schemas.openxmlformats.org/drawingml/2006/main"/>
-          <a:p xmlns:a="http://schemas.openxmlformats.org/drawingml/2006/main">
+          <a:prstGeom prst="rect">
+            <a:avLst/>
+          </a:prstGeom>
+          <a:noFill/>
+          <a:ln w="0">
+            <a:noFill/>
+          </a:ln>
+        </p:spPr>
+        <p:txBody>
+          <a:bodyPr>
+            <a:noAutofit/>
+          </a:bodyPr>
+          <a:lstStyle/>
+          <a:p>
             <a:pPr>
               <a:defRPr sz="2100" b="1">
                 <a:solidFill>
@@ -8075,37 +8102,38 @@
       <p:sp>
         <p:nvSpPr>
           <p:cNvPr id="7" name="">
-            <a:extLst xmlns:a="http://schemas.openxmlformats.org/drawingml/2006/main">
-              <a:ext uri="{FF2B5EF4-FFF2-40B4-BE49-F238E27FC236}">
-                <a16:creationId xmlns:a16="http://schemas.microsoft.com/office/drawing/2014/main" id="{8670551D-DA86-4EAE-85D4-1F139514BADF}"/>
-              </a:ext>
-            </a:extLst>
-          </p:cNvPr>
-          <p:cNvSpPr>
-            <a:spLocks xmlns:a="http://schemas.openxmlformats.org/drawingml/2006/main" noGrp="1"/>
-          </p:cNvSpPr>
-          <p:nvPr/>
-        </p:nvSpPr>
-        <p:spPr>
-          <a:xfrm xmlns:a="http://schemas.openxmlformats.org/drawingml/2006/main">
+            <a:extLst>
+              <a:ext uri="{FF2B5EF4-FFF2-40B4-BE49-F238E27FC236}">
+                <ns2:creationId id="{8670551D-DA86-4EAE-85D4-1F139514BADF}"/>
+              </a:ext>
+            </a:extLst>
+          </p:cNvPr>
+          <p:cNvSpPr>
+            <a:spLocks noGrp="1"/>
+          </p:cNvSpPr>
+          <p:nvPr/>
+        </p:nvSpPr>
+        <p:spPr>
+          <a:xfrm>
             <a:off x="742950" y="3648075"/>
             <a:ext cx="10668000" cy="581025"/>
           </a:xfrm>
-          <a:prstGeom xmlns:a="http://schemas.openxmlformats.org/drawingml/2006/main" prst="rect">
-            <a:avLst/>
-          </a:prstGeom>
-          <a:noFill xmlns:a="http://schemas.openxmlformats.org/drawingml/2006/main"/>
-          <a:ln xmlns:a="http://schemas.openxmlformats.org/drawingml/2006/main" w="0">
-            <a:noFill/>
-          </a:ln>
-        </p:spPr>
-        <p:txBody>
-          <a:bodyPr xmlns:a="http://schemas.openxmlformats.org/drawingml/2006/main">
-            <a:noAutofit/>
-          </a:bodyPr>
-          <a:lstStyle xmlns:a="http://schemas.openxmlformats.org/drawingml/2006/main"/>
-          <a:p xmlns:a="http://schemas.openxmlformats.org/drawingml/2006/main">
-            <a:pPr>
+          <a:prstGeom prst="rect">
+            <a:avLst/>
+          </a:prstGeom>
+          <a:noFill/>
+          <a:ln w="0">
+            <a:noFill/>
+          </a:ln>
+        </p:spPr>
+        <p:txBody>
+          <a:bodyPr>
+            <a:noAutofit/>
+          </a:bodyPr>
+          <a:lstStyle/>
+          <a:p>
+            <a:pPr>
+              <a:buNone/>
               <a:defRPr sz="1800" b="0">
                 <a:solidFill>
                   <a:srgbClr val="142735"/>
@@ -8124,7 +8152,7 @@
                 <a:ea typeface="Helvetica Neue"/>
                 <a:cs typeface="Helvetica Neue"/>
               </a:rPr>
-              <a:t>Sejm: 32 blocks became 4 turns with all 802 source parts preserved. This measures grouping, not ASR accuracy.</a:t>
+              <a:t>A 33.28-second Sejm pause now ends a turn despite the same S1 label. Raw sources and corrections stay saved.</a:t>
             </a:r>
           </a:p>
         </p:txBody>
@@ -8132,36 +8160,36 @@
       <p:sp>
         <p:nvSpPr>
           <p:cNvPr id="8" name="">
-            <a:extLst xmlns:a="http://schemas.openxmlformats.org/drawingml/2006/main">
-              <a:ext uri="{FF2B5EF4-FFF2-40B4-BE49-F238E27FC236}">
-                <a16:creationId xmlns:a16="http://schemas.microsoft.com/office/drawing/2014/main" id="{5F61AE17-2FB6-4126-841E-BC72EBE0F916}"/>
-              </a:ext>
-            </a:extLst>
-          </p:cNvPr>
-          <p:cNvSpPr>
-            <a:spLocks xmlns:a="http://schemas.openxmlformats.org/drawingml/2006/main" noGrp="1"/>
-          </p:cNvSpPr>
-          <p:nvPr/>
-        </p:nvSpPr>
-        <p:spPr>
-          <a:xfrm xmlns:a="http://schemas.openxmlformats.org/drawingml/2006/main">
+            <a:extLst>
+              <a:ext uri="{FF2B5EF4-FFF2-40B4-BE49-F238E27FC236}">
+                <ns2:creationId id="{5F61AE17-2FB6-4126-841E-BC72EBE0F916}"/>
+              </a:ext>
+            </a:extLst>
+          </p:cNvPr>
+          <p:cNvSpPr>
+            <a:spLocks noGrp="1"/>
+          </p:cNvSpPr>
+          <p:nvPr/>
+        </p:nvSpPr>
+        <p:spPr>
+          <a:xfrm>
             <a:off x="742950" y="4181475"/>
             <a:ext cx="10668000" cy="352425"/>
           </a:xfrm>
-          <a:prstGeom xmlns:a="http://schemas.openxmlformats.org/drawingml/2006/main" prst="rect">
-            <a:avLst/>
-          </a:prstGeom>
-          <a:noFill xmlns:a="http://schemas.openxmlformats.org/drawingml/2006/main"/>
-          <a:ln xmlns:a="http://schemas.openxmlformats.org/drawingml/2006/main" w="0">
-            <a:noFill/>
-          </a:ln>
-        </p:spPr>
-        <p:txBody>
-          <a:bodyPr xmlns:a="http://schemas.openxmlformats.org/drawingml/2006/main">
-            <a:noAutofit/>
-          </a:bodyPr>
-          <a:lstStyle xmlns:a="http://schemas.openxmlformats.org/drawingml/2006/main"/>
-          <a:p xmlns:a="http://schemas.openxmlformats.org/drawingml/2006/main">
+          <a:prstGeom prst="rect">
+            <a:avLst/>
+          </a:prstGeom>
+          <a:noFill/>
+          <a:ln w="0">
+            <a:noFill/>
+          </a:ln>
+        </p:spPr>
+        <p:txBody>
+          <a:bodyPr>
+            <a:noAutofit/>
+          </a:bodyPr>
+          <a:lstStyle/>
+          <a:p>
             <a:pPr>
               <a:defRPr sz="2100" b="1">
                 <a:solidFill>
@@ -8189,36 +8217,36 @@
       <p:sp>
         <p:nvSpPr>
           <p:cNvPr id="9" name="">
-            <a:extLst xmlns:a="http://schemas.openxmlformats.org/drawingml/2006/main">
-              <a:ext uri="{FF2B5EF4-FFF2-40B4-BE49-F238E27FC236}">
-                <a16:creationId xmlns:a16="http://schemas.microsoft.com/office/drawing/2014/main" id="{7754E09B-DE7D-4924-96D3-FB5E42F8CEF3}"/>
-              </a:ext>
-            </a:extLst>
-          </p:cNvPr>
-          <p:cNvSpPr>
-            <a:spLocks xmlns:a="http://schemas.openxmlformats.org/drawingml/2006/main" noGrp="1"/>
-          </p:cNvSpPr>
-          <p:nvPr/>
-        </p:nvSpPr>
-        <p:spPr>
-          <a:xfrm xmlns:a="http://schemas.openxmlformats.org/drawingml/2006/main">
+            <a:extLst>
+              <a:ext uri="{FF2B5EF4-FFF2-40B4-BE49-F238E27FC236}">
+                <ns2:creationId id="{7754E09B-DE7D-4924-96D3-FB5E42F8CEF3}"/>
+              </a:ext>
+            </a:extLst>
+          </p:cNvPr>
+          <p:cNvSpPr>
+            <a:spLocks noGrp="1"/>
+          </p:cNvSpPr>
+          <p:nvPr/>
+        </p:nvSpPr>
+        <p:spPr>
+          <a:xfrm>
             <a:off x="742950" y="4562475"/>
             <a:ext cx="10668000" cy="581025"/>
           </a:xfrm>
-          <a:prstGeom xmlns:a="http://schemas.openxmlformats.org/drawingml/2006/main" prst="rect">
-            <a:avLst/>
-          </a:prstGeom>
-          <a:noFill xmlns:a="http://schemas.openxmlformats.org/drawingml/2006/main"/>
-          <a:ln xmlns:a="http://schemas.openxmlformats.org/drawingml/2006/main" w="0">
-            <a:noFill/>
-          </a:ln>
-        </p:spPr>
-        <p:txBody>
-          <a:bodyPr xmlns:a="http://schemas.openxmlformats.org/drawingml/2006/main">
-            <a:noAutofit/>
-          </a:bodyPr>
-          <a:lstStyle xmlns:a="http://schemas.openxmlformats.org/drawingml/2006/main"/>
-          <a:p xmlns:a="http://schemas.openxmlformats.org/drawingml/2006/main">
+          <a:prstGeom prst="rect">
+            <a:avLst/>
+          </a:prstGeom>
+          <a:noFill/>
+          <a:ln w="0">
+            <a:noFill/>
+          </a:ln>
+        </p:spPr>
+        <p:txBody>
+          <a:bodyPr>
+            <a:noAutofit/>
+          </a:bodyPr>
+          <a:lstStyle/>
+          <a:p>
             <a:pPr>
               <a:defRPr sz="1800" b="0">
                 <a:solidFill>
@@ -8246,36 +8274,36 @@
       <p:sp>
         <p:nvSpPr>
           <p:cNvPr id="10" name="">
-            <a:extLst xmlns:a="http://schemas.openxmlformats.org/drawingml/2006/main">
-              <a:ext uri="{FF2B5EF4-FFF2-40B4-BE49-F238E27FC236}">
-                <a16:creationId xmlns:a16="http://schemas.microsoft.com/office/drawing/2014/main" id="{C61EAF9C-A717-4174-9E65-C910678CAB06}"/>
-              </a:ext>
-            </a:extLst>
-          </p:cNvPr>
-          <p:cNvSpPr>
-            <a:spLocks xmlns:a="http://schemas.openxmlformats.org/drawingml/2006/main" noGrp="1"/>
-          </p:cNvSpPr>
-          <p:nvPr/>
-        </p:nvSpPr>
-        <p:spPr>
-          <a:xfrm xmlns:a="http://schemas.openxmlformats.org/drawingml/2006/main">
+            <a:extLst>
+              <a:ext uri="{FF2B5EF4-FFF2-40B4-BE49-F238E27FC236}">
+                <ns2:creationId id="{C61EAF9C-A717-4174-9E65-C910678CAB06}"/>
+              </a:ext>
+            </a:extLst>
+          </p:cNvPr>
+          <p:cNvSpPr>
+            <a:spLocks noGrp="1"/>
+          </p:cNvSpPr>
+          <p:nvPr/>
+        </p:nvSpPr>
+        <p:spPr>
+          <a:xfrm>
             <a:off x="742950" y="5095875"/>
             <a:ext cx="10668000" cy="352425"/>
           </a:xfrm>
-          <a:prstGeom xmlns:a="http://schemas.openxmlformats.org/drawingml/2006/main" prst="rect">
-            <a:avLst/>
-          </a:prstGeom>
-          <a:noFill xmlns:a="http://schemas.openxmlformats.org/drawingml/2006/main"/>
-          <a:ln xmlns:a="http://schemas.openxmlformats.org/drawingml/2006/main" w="0">
-            <a:noFill/>
-          </a:ln>
-        </p:spPr>
-        <p:txBody>
-          <a:bodyPr xmlns:a="http://schemas.openxmlformats.org/drawingml/2006/main">
-            <a:noAutofit/>
-          </a:bodyPr>
-          <a:lstStyle xmlns:a="http://schemas.openxmlformats.org/drawingml/2006/main"/>
-          <a:p xmlns:a="http://schemas.openxmlformats.org/drawingml/2006/main">
+          <a:prstGeom prst="rect">
+            <a:avLst/>
+          </a:prstGeom>
+          <a:noFill/>
+          <a:ln w="0">
+            <a:noFill/>
+          </a:ln>
+        </p:spPr>
+        <p:txBody>
+          <a:bodyPr>
+            <a:noAutofit/>
+          </a:bodyPr>
+          <a:lstStyle/>
+          <a:p>
             <a:pPr>
               <a:defRPr sz="2100" b="1">
                 <a:solidFill>
@@ -8303,36 +8331,36 @@
       <p:sp>
         <p:nvSpPr>
           <p:cNvPr id="11" name="">
-            <a:extLst xmlns:a="http://schemas.openxmlformats.org/drawingml/2006/main">
-              <a:ext uri="{FF2B5EF4-FFF2-40B4-BE49-F238E27FC236}">
-                <a16:creationId xmlns:a16="http://schemas.microsoft.com/office/drawing/2014/main" id="{81B40AF3-8D85-4879-B87C-0D0F5C224672}"/>
-              </a:ext>
-            </a:extLst>
-          </p:cNvPr>
-          <p:cNvSpPr>
-            <a:spLocks xmlns:a="http://schemas.openxmlformats.org/drawingml/2006/main" noGrp="1"/>
-          </p:cNvSpPr>
-          <p:nvPr/>
-        </p:nvSpPr>
-        <p:spPr>
-          <a:xfrm xmlns:a="http://schemas.openxmlformats.org/drawingml/2006/main">
+            <a:extLst>
+              <a:ext uri="{FF2B5EF4-FFF2-40B4-BE49-F238E27FC236}">
+                <ns2:creationId id="{81B40AF3-8D85-4879-B87C-0D0F5C224672}"/>
+              </a:ext>
+            </a:extLst>
+          </p:cNvPr>
+          <p:cNvSpPr>
+            <a:spLocks noGrp="1"/>
+          </p:cNvSpPr>
+          <p:nvPr/>
+        </p:nvSpPr>
+        <p:spPr>
+          <a:xfrm>
             <a:off x="742950" y="5476875"/>
             <a:ext cx="10668000" cy="581025"/>
           </a:xfrm>
-          <a:prstGeom xmlns:a="http://schemas.openxmlformats.org/drawingml/2006/main" prst="rect">
-            <a:avLst/>
-          </a:prstGeom>
-          <a:noFill xmlns:a="http://schemas.openxmlformats.org/drawingml/2006/main"/>
-          <a:ln xmlns:a="http://schemas.openxmlformats.org/drawingml/2006/main" w="0">
-            <a:noFill/>
-          </a:ln>
-        </p:spPr>
-        <p:txBody>
-          <a:bodyPr xmlns:a="http://schemas.openxmlformats.org/drawingml/2006/main">
-            <a:noAutofit/>
-          </a:bodyPr>
-          <a:lstStyle xmlns:a="http://schemas.openxmlformats.org/drawingml/2006/main"/>
-          <a:p xmlns:a="http://schemas.openxmlformats.org/drawingml/2006/main">
+          <a:prstGeom prst="rect">
+            <a:avLst/>
+          </a:prstGeom>
+          <a:noFill/>
+          <a:ln w="0">
+            <a:noFill/>
+          </a:ln>
+        </p:spPr>
+        <p:txBody>
+          <a:bodyPr>
+            <a:noAutofit/>
+          </a:bodyPr>
+          <a:lstStyle/>
+          <a:p>
             <a:pPr>
               <a:defRPr sz="1800" b="0">
                 <a:solidFill>
@@ -8360,36 +8388,36 @@
       <p:sp>
         <p:nvSpPr>
           <p:cNvPr id="12" name="">
-            <a:extLst xmlns:a="http://schemas.openxmlformats.org/drawingml/2006/main">
-              <a:ext uri="{FF2B5EF4-FFF2-40B4-BE49-F238E27FC236}">
-                <a16:creationId xmlns:a16="http://schemas.microsoft.com/office/drawing/2014/main" id="{03F90AA5-33B8-41C0-B5DF-E444903515D9}"/>
-              </a:ext>
-            </a:extLst>
-          </p:cNvPr>
-          <p:cNvSpPr>
-            <a:spLocks xmlns:a="http://schemas.openxmlformats.org/drawingml/2006/main" noGrp="1"/>
-          </p:cNvSpPr>
-          <p:nvPr/>
-        </p:nvSpPr>
-        <p:spPr>
-          <a:xfrm xmlns:a="http://schemas.openxmlformats.org/drawingml/2006/main">
+            <a:extLst>
+              <a:ext uri="{FF2B5EF4-FFF2-40B4-BE49-F238E27FC236}">
+                <ns2:creationId id="{03F90AA5-33B8-41C0-B5DF-E444903515D9}"/>
+              </a:ext>
+            </a:extLst>
+          </p:cNvPr>
+          <p:cNvSpPr>
+            <a:spLocks noGrp="1"/>
+          </p:cNvSpPr>
+          <p:nvPr/>
+        </p:nvSpPr>
+        <p:spPr>
+          <a:xfrm>
             <a:off x="742950" y="6257925"/>
             <a:ext cx="10668000" cy="428625"/>
           </a:xfrm>
-          <a:prstGeom xmlns:a="http://schemas.openxmlformats.org/drawingml/2006/main" prst="rect">
-            <a:avLst/>
-          </a:prstGeom>
-          <a:noFill xmlns:a="http://schemas.openxmlformats.org/drawingml/2006/main"/>
-          <a:ln xmlns:a="http://schemas.openxmlformats.org/drawingml/2006/main" w="0">
-            <a:noFill/>
-          </a:ln>
-        </p:spPr>
-        <p:txBody>
-          <a:bodyPr xmlns:a="http://schemas.openxmlformats.org/drawingml/2006/main">
-            <a:noAutofit/>
-          </a:bodyPr>
-          <a:lstStyle xmlns:a="http://schemas.openxmlformats.org/drawingml/2006/main"/>
-          <a:p xmlns:a="http://schemas.openxmlformats.org/drawingml/2006/main">
+          <a:prstGeom prst="rect">
+            <a:avLst/>
+          </a:prstGeom>
+          <a:noFill/>
+          <a:ln w="0">
+            <a:noFill/>
+          </a:ln>
+        </p:spPr>
+        <p:txBody>
+          <a:bodyPr>
+            <a:noAutofit/>
+          </a:bodyPr>
+          <a:lstStyle/>
+          <a:p>
             <a:pPr>
               <a:defRPr sz="1575" b="0">
                 <a:solidFill>
@@ -8417,7 +8445,7 @@
     </p:spTree>
     <p:extLst>
       <p:ext uri="{BB962C8B-B14F-4D97-AF65-F5344CB8AC3E}">
-        <p14:creationId xmlns:p14="http://schemas.microsoft.com/office/powerpoint/2010/main" val="1811565807"/>
+        <ns3:creationId val="1811565807"/>
       </p:ext>
     </p:extLst>
   </p:cSld>
@@ -9457,11 +9485,11 @@
 </file>
 
 <file path=ppt/slides/slide21.xml><?xml version="1.0" encoding="utf-8"?>
-<p:sld xmlns:p="http://schemas.openxmlformats.org/presentationml/2006/main">
+<p:sld xmlns:a="http://schemas.openxmlformats.org/drawingml/2006/main" xmlns:ns2="http://schemas.microsoft.com/office/drawing/2014/main" xmlns:ns3="http://schemas.microsoft.com/office/powerpoint/2010/main" xmlns:p="http://schemas.openxmlformats.org/presentationml/2006/main">
   <p:cSld>
     <p:bg>
       <p:bgPr>
-        <a:solidFill xmlns:a="http://schemas.openxmlformats.org/drawingml/2006/main">
+        <a:solidFill>
           <a:srgbClr val="FFFFFF"/>
         </a:solidFill>
       </p:bgPr>
@@ -9473,41 +9501,41 @@
         <p:nvPr/>
       </p:nvGrpSpPr>
       <p:grpSpPr>
-        <a:xfrm xmlns:a="http://schemas.openxmlformats.org/drawingml/2006/main"/>
+        <a:xfrm/>
       </p:grpSpPr>
       <p:sp>
         <p:nvSpPr>
           <p:cNvPr id="11" name="">
-            <a:extLst xmlns:a="http://schemas.openxmlformats.org/drawingml/2006/main">
-              <a:ext uri="{FF2B5EF4-FFF2-40B4-BE49-F238E27FC236}">
-                <a16:creationId xmlns:a16="http://schemas.microsoft.com/office/drawing/2014/main" id="{3AB3DFBC-F0F6-47F1-8972-66D1E5A28583}"/>
-              </a:ext>
-            </a:extLst>
-          </p:cNvPr>
-          <p:cNvSpPr>
-            <a:spLocks xmlns:a="http://schemas.openxmlformats.org/drawingml/2006/main" noGrp="1"/>
-          </p:cNvSpPr>
-          <p:nvPr/>
-        </p:nvSpPr>
-        <p:spPr>
-          <a:xfrm xmlns:a="http://schemas.openxmlformats.org/drawingml/2006/main">
+            <a:extLst>
+              <a:ext uri="{FF2B5EF4-FFF2-40B4-BE49-F238E27FC236}">
+                <ns2:creationId id="{3AB3DFBC-F0F6-47F1-8972-66D1E5A28583}"/>
+              </a:ext>
+            </a:extLst>
+          </p:cNvPr>
+          <p:cNvSpPr>
+            <a:spLocks noGrp="1"/>
+          </p:cNvSpPr>
+          <p:nvPr/>
+        </p:nvSpPr>
+        <p:spPr>
+          <a:xfrm>
             <a:off x="742950" y="447675"/>
             <a:ext cx="10668000" cy="742950"/>
           </a:xfrm>
-          <a:prstGeom xmlns:a="http://schemas.openxmlformats.org/drawingml/2006/main" prst="rect">
-            <a:avLst/>
-          </a:prstGeom>
-          <a:noFill xmlns:a="http://schemas.openxmlformats.org/drawingml/2006/main"/>
-          <a:ln xmlns:a="http://schemas.openxmlformats.org/drawingml/2006/main" w="0">
-            <a:noFill/>
-          </a:ln>
-        </p:spPr>
-        <p:txBody>
-          <a:bodyPr xmlns:a="http://schemas.openxmlformats.org/drawingml/2006/main">
-            <a:noAutofit/>
-          </a:bodyPr>
-          <a:lstStyle xmlns:a="http://schemas.openxmlformats.org/drawingml/2006/main"/>
-          <a:p xmlns:a="http://schemas.openxmlformats.org/drawingml/2006/main">
+          <a:prstGeom prst="rect">
+            <a:avLst/>
+          </a:prstGeom>
+          <a:noFill/>
+          <a:ln w="0">
+            <a:noFill/>
+          </a:ln>
+        </p:spPr>
+        <p:txBody>
+          <a:bodyPr>
+            <a:noAutofit/>
+          </a:bodyPr>
+          <a:lstStyle/>
+          <a:p>
             <a:pPr>
               <a:defRPr sz="3000" b="1">
                 <a:solidFill>
@@ -9535,36 +9563,36 @@
       <p:sp>
         <p:nvSpPr>
           <p:cNvPr id="2" name="">
-            <a:extLst xmlns:a="http://schemas.openxmlformats.org/drawingml/2006/main">
-              <a:ext uri="{FF2B5EF4-FFF2-40B4-BE49-F238E27FC236}">
-                <a16:creationId xmlns:a16="http://schemas.microsoft.com/office/drawing/2014/main" id="{0BD9E482-447F-4CF4-8118-BD98DB5CDAC1}"/>
-              </a:ext>
-            </a:extLst>
-          </p:cNvPr>
-          <p:cNvSpPr>
-            <a:spLocks xmlns:a="http://schemas.openxmlformats.org/drawingml/2006/main" noGrp="1"/>
-          </p:cNvSpPr>
-          <p:nvPr/>
-        </p:nvSpPr>
-        <p:spPr>
-          <a:xfrm xmlns:a="http://schemas.openxmlformats.org/drawingml/2006/main">
+            <a:extLst>
+              <a:ext uri="{FF2B5EF4-FFF2-40B4-BE49-F238E27FC236}">
+                <ns2:creationId id="{0BD9E482-447F-4CF4-8118-BD98DB5CDAC1}"/>
+              </a:ext>
+            </a:extLst>
+          </p:cNvPr>
+          <p:cNvSpPr>
+            <a:spLocks noGrp="1"/>
+          </p:cNvSpPr>
+          <p:nvPr/>
+        </p:nvSpPr>
+        <p:spPr>
+          <a:xfrm>
             <a:off x="742950" y="1438275"/>
             <a:ext cx="10668000" cy="352425"/>
           </a:xfrm>
-          <a:prstGeom xmlns:a="http://schemas.openxmlformats.org/drawingml/2006/main" prst="rect">
-            <a:avLst/>
-          </a:prstGeom>
-          <a:noFill xmlns:a="http://schemas.openxmlformats.org/drawingml/2006/main"/>
-          <a:ln xmlns:a="http://schemas.openxmlformats.org/drawingml/2006/main" w="0">
-            <a:noFill/>
-          </a:ln>
-        </p:spPr>
-        <p:txBody>
-          <a:bodyPr xmlns:a="http://schemas.openxmlformats.org/drawingml/2006/main">
-            <a:noAutofit/>
-          </a:bodyPr>
-          <a:lstStyle xmlns:a="http://schemas.openxmlformats.org/drawingml/2006/main"/>
-          <a:p xmlns:a="http://schemas.openxmlformats.org/drawingml/2006/main">
+          <a:prstGeom prst="rect">
+            <a:avLst/>
+          </a:prstGeom>
+          <a:noFill/>
+          <a:ln w="0">
+            <a:noFill/>
+          </a:ln>
+        </p:spPr>
+        <p:txBody>
+          <a:bodyPr>
+            <a:noAutofit/>
+          </a:bodyPr>
+          <a:lstStyle/>
+          <a:p>
             <a:pPr>
               <a:defRPr sz="2100" b="1">
                 <a:solidFill>
@@ -9592,36 +9620,36 @@
       <p:sp>
         <p:nvSpPr>
           <p:cNvPr id="3" name="">
-            <a:extLst xmlns:a="http://schemas.openxmlformats.org/drawingml/2006/main">
-              <a:ext uri="{FF2B5EF4-FFF2-40B4-BE49-F238E27FC236}">
-                <a16:creationId xmlns:a16="http://schemas.microsoft.com/office/drawing/2014/main" id="{141FF60C-3544-4CDA-87BD-F11D59DDFC09}"/>
-              </a:ext>
-            </a:extLst>
-          </p:cNvPr>
-          <p:cNvSpPr>
-            <a:spLocks xmlns:a="http://schemas.openxmlformats.org/drawingml/2006/main" noGrp="1"/>
-          </p:cNvSpPr>
-          <p:nvPr/>
-        </p:nvSpPr>
-        <p:spPr>
-          <a:xfrm xmlns:a="http://schemas.openxmlformats.org/drawingml/2006/main">
+            <a:extLst>
+              <a:ext uri="{FF2B5EF4-FFF2-40B4-BE49-F238E27FC236}">
+                <ns2:creationId id="{141FF60C-3544-4CDA-87BD-F11D59DDFC09}"/>
+              </a:ext>
+            </a:extLst>
+          </p:cNvPr>
+          <p:cNvSpPr>
+            <a:spLocks noGrp="1"/>
+          </p:cNvSpPr>
+          <p:nvPr/>
+        </p:nvSpPr>
+        <p:spPr>
+          <a:xfrm>
             <a:off x="742950" y="1819275"/>
             <a:ext cx="10668000" cy="581025"/>
           </a:xfrm>
-          <a:prstGeom xmlns:a="http://schemas.openxmlformats.org/drawingml/2006/main" prst="rect">
-            <a:avLst/>
-          </a:prstGeom>
-          <a:noFill xmlns:a="http://schemas.openxmlformats.org/drawingml/2006/main"/>
-          <a:ln xmlns:a="http://schemas.openxmlformats.org/drawingml/2006/main" w="0">
-            <a:noFill/>
-          </a:ln>
-        </p:spPr>
-        <p:txBody>
-          <a:bodyPr xmlns:a="http://schemas.openxmlformats.org/drawingml/2006/main">
-            <a:noAutofit/>
-          </a:bodyPr>
-          <a:lstStyle xmlns:a="http://schemas.openxmlformats.org/drawingml/2006/main"/>
-          <a:p xmlns:a="http://schemas.openxmlformats.org/drawingml/2006/main">
+          <a:prstGeom prst="rect">
+            <a:avLst/>
+          </a:prstGeom>
+          <a:noFill/>
+          <a:ln w="0">
+            <a:noFill/>
+          </a:ln>
+        </p:spPr>
+        <p:txBody>
+          <a:bodyPr>
+            <a:noAutofit/>
+          </a:bodyPr>
+          <a:lstStyle/>
+          <a:p>
             <a:pPr>
               <a:defRPr sz="1800" b="0">
                 <a:solidFill>
@@ -9649,36 +9677,36 @@
       <p:sp>
         <p:nvSpPr>
           <p:cNvPr id="4" name="">
-            <a:extLst xmlns:a="http://schemas.openxmlformats.org/drawingml/2006/main">
-              <a:ext uri="{FF2B5EF4-FFF2-40B4-BE49-F238E27FC236}">
-                <a16:creationId xmlns:a16="http://schemas.microsoft.com/office/drawing/2014/main" id="{E64609AC-F849-49DF-A342-0CCD6F1B07C8}"/>
-              </a:ext>
-            </a:extLst>
-          </p:cNvPr>
-          <p:cNvSpPr>
-            <a:spLocks xmlns:a="http://schemas.openxmlformats.org/drawingml/2006/main" noGrp="1"/>
-          </p:cNvSpPr>
-          <p:nvPr/>
-        </p:nvSpPr>
-        <p:spPr>
-          <a:xfrm xmlns:a="http://schemas.openxmlformats.org/drawingml/2006/main">
+            <a:extLst>
+              <a:ext uri="{FF2B5EF4-FFF2-40B4-BE49-F238E27FC236}">
+                <ns2:creationId id="{E64609AC-F849-49DF-A342-0CCD6F1B07C8}"/>
+              </a:ext>
+            </a:extLst>
+          </p:cNvPr>
+          <p:cNvSpPr>
+            <a:spLocks noGrp="1"/>
+          </p:cNvSpPr>
+          <p:nvPr/>
+        </p:nvSpPr>
+        <p:spPr>
+          <a:xfrm>
             <a:off x="742950" y="2533650"/>
             <a:ext cx="10668000" cy="352425"/>
           </a:xfrm>
-          <a:prstGeom xmlns:a="http://schemas.openxmlformats.org/drawingml/2006/main" prst="rect">
-            <a:avLst/>
-          </a:prstGeom>
-          <a:noFill xmlns:a="http://schemas.openxmlformats.org/drawingml/2006/main"/>
-          <a:ln xmlns:a="http://schemas.openxmlformats.org/drawingml/2006/main" w="0">
-            <a:noFill/>
-          </a:ln>
-        </p:spPr>
-        <p:txBody>
-          <a:bodyPr xmlns:a="http://schemas.openxmlformats.org/drawingml/2006/main">
-            <a:noAutofit/>
-          </a:bodyPr>
-          <a:lstStyle xmlns:a="http://schemas.openxmlformats.org/drawingml/2006/main"/>
-          <a:p xmlns:a="http://schemas.openxmlformats.org/drawingml/2006/main">
+          <a:prstGeom prst="rect">
+            <a:avLst/>
+          </a:prstGeom>
+          <a:noFill/>
+          <a:ln w="0">
+            <a:noFill/>
+          </a:ln>
+        </p:spPr>
+        <p:txBody>
+          <a:bodyPr>
+            <a:noAutofit/>
+          </a:bodyPr>
+          <a:lstStyle/>
+          <a:p>
             <a:pPr>
               <a:defRPr sz="2100" b="1">
                 <a:solidFill>
@@ -9706,36 +9734,36 @@
       <p:sp>
         <p:nvSpPr>
           <p:cNvPr id="5" name="">
-            <a:extLst xmlns:a="http://schemas.openxmlformats.org/drawingml/2006/main">
-              <a:ext uri="{FF2B5EF4-FFF2-40B4-BE49-F238E27FC236}">
-                <a16:creationId xmlns:a16="http://schemas.microsoft.com/office/drawing/2014/main" id="{A6E9CE8A-691D-469C-B1EA-8A80EF61326E}"/>
-              </a:ext>
-            </a:extLst>
-          </p:cNvPr>
-          <p:cNvSpPr>
-            <a:spLocks xmlns:a="http://schemas.openxmlformats.org/drawingml/2006/main" noGrp="1"/>
-          </p:cNvSpPr>
-          <p:nvPr/>
-        </p:nvSpPr>
-        <p:spPr>
-          <a:xfrm xmlns:a="http://schemas.openxmlformats.org/drawingml/2006/main">
+            <a:extLst>
+              <a:ext uri="{FF2B5EF4-FFF2-40B4-BE49-F238E27FC236}">
+                <ns2:creationId id="{A6E9CE8A-691D-469C-B1EA-8A80EF61326E}"/>
+              </a:ext>
+            </a:extLst>
+          </p:cNvPr>
+          <p:cNvSpPr>
+            <a:spLocks noGrp="1"/>
+          </p:cNvSpPr>
+          <p:nvPr/>
+        </p:nvSpPr>
+        <p:spPr>
+          <a:xfrm>
             <a:off x="742950" y="2914650"/>
             <a:ext cx="10668000" cy="581025"/>
           </a:xfrm>
-          <a:prstGeom xmlns:a="http://schemas.openxmlformats.org/drawingml/2006/main" prst="rect">
-            <a:avLst/>
-          </a:prstGeom>
-          <a:noFill xmlns:a="http://schemas.openxmlformats.org/drawingml/2006/main"/>
-          <a:ln xmlns:a="http://schemas.openxmlformats.org/drawingml/2006/main" w="0">
-            <a:noFill/>
-          </a:ln>
-        </p:spPr>
-        <p:txBody>
-          <a:bodyPr xmlns:a="http://schemas.openxmlformats.org/drawingml/2006/main">
-            <a:noAutofit/>
-          </a:bodyPr>
-          <a:lstStyle xmlns:a="http://schemas.openxmlformats.org/drawingml/2006/main"/>
-          <a:p xmlns:a="http://schemas.openxmlformats.org/drawingml/2006/main">
+          <a:prstGeom prst="rect">
+            <a:avLst/>
+          </a:prstGeom>
+          <a:noFill/>
+          <a:ln w="0">
+            <a:noFill/>
+          </a:ln>
+        </p:spPr>
+        <p:txBody>
+          <a:bodyPr>
+            <a:noAutofit/>
+          </a:bodyPr>
+          <a:lstStyle/>
+          <a:p>
             <a:pPr>
               <a:defRPr sz="1800" b="0">
                 <a:solidFill>
@@ -9763,36 +9791,36 @@
       <p:sp>
         <p:nvSpPr>
           <p:cNvPr id="6" name="">
-            <a:extLst xmlns:a="http://schemas.openxmlformats.org/drawingml/2006/main">
-              <a:ext uri="{FF2B5EF4-FFF2-40B4-BE49-F238E27FC236}">
-                <a16:creationId xmlns:a16="http://schemas.microsoft.com/office/drawing/2014/main" id="{CA3F09F6-B96E-4342-B315-2558B71B26A3}"/>
-              </a:ext>
-            </a:extLst>
-          </p:cNvPr>
-          <p:cNvSpPr>
-            <a:spLocks xmlns:a="http://schemas.openxmlformats.org/drawingml/2006/main" noGrp="1"/>
-          </p:cNvSpPr>
-          <p:nvPr/>
-        </p:nvSpPr>
-        <p:spPr>
-          <a:xfrm xmlns:a="http://schemas.openxmlformats.org/drawingml/2006/main">
+            <a:extLst>
+              <a:ext uri="{FF2B5EF4-FFF2-40B4-BE49-F238E27FC236}">
+                <ns2:creationId id="{CA3F09F6-B96E-4342-B315-2558B71B26A3}"/>
+              </a:ext>
+            </a:extLst>
+          </p:cNvPr>
+          <p:cNvSpPr>
+            <a:spLocks noGrp="1"/>
+          </p:cNvSpPr>
+          <p:nvPr/>
+        </p:nvSpPr>
+        <p:spPr>
+          <a:xfrm>
             <a:off x="742950" y="3629025"/>
             <a:ext cx="10668000" cy="352425"/>
           </a:xfrm>
-          <a:prstGeom xmlns:a="http://schemas.openxmlformats.org/drawingml/2006/main" prst="rect">
-            <a:avLst/>
-          </a:prstGeom>
-          <a:noFill xmlns:a="http://schemas.openxmlformats.org/drawingml/2006/main"/>
-          <a:ln xmlns:a="http://schemas.openxmlformats.org/drawingml/2006/main" w="0">
-            <a:noFill/>
-          </a:ln>
-        </p:spPr>
-        <p:txBody>
-          <a:bodyPr xmlns:a="http://schemas.openxmlformats.org/drawingml/2006/main">
-            <a:noAutofit/>
-          </a:bodyPr>
-          <a:lstStyle xmlns:a="http://schemas.openxmlformats.org/drawingml/2006/main"/>
-          <a:p xmlns:a="http://schemas.openxmlformats.org/drawingml/2006/main">
+          <a:prstGeom prst="rect">
+            <a:avLst/>
+          </a:prstGeom>
+          <a:noFill/>
+          <a:ln w="0">
+            <a:noFill/>
+          </a:ln>
+        </p:spPr>
+        <p:txBody>
+          <a:bodyPr>
+            <a:noAutofit/>
+          </a:bodyPr>
+          <a:lstStyle/>
+          <a:p>
             <a:pPr>
               <a:defRPr sz="2100" b="1">
                 <a:solidFill>
@@ -9820,37 +9848,38 @@
       <p:sp>
         <p:nvSpPr>
           <p:cNvPr id="7" name="">
-            <a:extLst xmlns:a="http://schemas.openxmlformats.org/drawingml/2006/main">
-              <a:ext uri="{FF2B5EF4-FFF2-40B4-BE49-F238E27FC236}">
-                <a16:creationId xmlns:a16="http://schemas.microsoft.com/office/drawing/2014/main" id="{72FA42DB-C3B2-4B74-B7FC-F5E70CE0FE3E}"/>
-              </a:ext>
-            </a:extLst>
-          </p:cNvPr>
-          <p:cNvSpPr>
-            <a:spLocks xmlns:a="http://schemas.openxmlformats.org/drawingml/2006/main" noGrp="1"/>
-          </p:cNvSpPr>
-          <p:nvPr/>
-        </p:nvSpPr>
-        <p:spPr>
-          <a:xfrm xmlns:a="http://schemas.openxmlformats.org/drawingml/2006/main">
+            <a:extLst>
+              <a:ext uri="{FF2B5EF4-FFF2-40B4-BE49-F238E27FC236}">
+                <ns2:creationId id="{72FA42DB-C3B2-4B74-B7FC-F5E70CE0FE3E}"/>
+              </a:ext>
+            </a:extLst>
+          </p:cNvPr>
+          <p:cNvSpPr>
+            <a:spLocks noGrp="1"/>
+          </p:cNvSpPr>
+          <p:nvPr/>
+        </p:nvSpPr>
+        <p:spPr>
+          <a:xfrm>
             <a:off x="742950" y="4010025"/>
             <a:ext cx="10668000" cy="581025"/>
           </a:xfrm>
-          <a:prstGeom xmlns:a="http://schemas.openxmlformats.org/drawingml/2006/main" prst="rect">
-            <a:avLst/>
-          </a:prstGeom>
-          <a:noFill xmlns:a="http://schemas.openxmlformats.org/drawingml/2006/main"/>
-          <a:ln xmlns:a="http://schemas.openxmlformats.org/drawingml/2006/main" w="0">
-            <a:noFill/>
-          </a:ln>
-        </p:spPr>
-        <p:txBody>
-          <a:bodyPr xmlns:a="http://schemas.openxmlformats.org/drawingml/2006/main">
-            <a:noAutofit/>
-          </a:bodyPr>
-          <a:lstStyle xmlns:a="http://schemas.openxmlformats.org/drawingml/2006/main"/>
-          <a:p xmlns:a="http://schemas.openxmlformats.org/drawingml/2006/main">
-            <a:pPr>
+          <a:prstGeom prst="rect">
+            <a:avLst/>
+          </a:prstGeom>
+          <a:noFill/>
+          <a:ln w="0">
+            <a:noFill/>
+          </a:ln>
+        </p:spPr>
+        <p:txBody>
+          <a:bodyPr>
+            <a:noAutofit/>
+          </a:bodyPr>
+          <a:lstStyle/>
+          <a:p>
+            <a:pPr>
+              <a:buNone/>
               <a:defRPr sz="1800" b="0">
                 <a:solidFill>
                   <a:srgbClr val="142735"/>
@@ -9869,7 +9898,7 @@
                 <a:ea typeface="Helvetica Neue"/>
                 <a:cs typeface="Helvetica Neue"/>
               </a:rPr>
-              <a:t>Evaluate semantic continuity and ambiguous speaker joins. Keep every segmentation control explicit and reproducible.</a:t>
+              <a:t>Long silence ends a turn; short pauses can join. Validate semantic continuity and ambiguous voice joins next.</a:t>
             </a:r>
           </a:p>
         </p:txBody>
@@ -9877,36 +9906,36 @@
       <p:sp>
         <p:nvSpPr>
           <p:cNvPr id="8" name="">
-            <a:extLst xmlns:a="http://schemas.openxmlformats.org/drawingml/2006/main">
-              <a:ext uri="{FF2B5EF4-FFF2-40B4-BE49-F238E27FC236}">
-                <a16:creationId xmlns:a16="http://schemas.microsoft.com/office/drawing/2014/main" id="{1786DD50-2954-4CFA-8861-259EB79A2EBD}"/>
-              </a:ext>
-            </a:extLst>
-          </p:cNvPr>
-          <p:cNvSpPr>
-            <a:spLocks xmlns:a="http://schemas.openxmlformats.org/drawingml/2006/main" noGrp="1"/>
-          </p:cNvSpPr>
-          <p:nvPr/>
-        </p:nvSpPr>
-        <p:spPr>
-          <a:xfrm xmlns:a="http://schemas.openxmlformats.org/drawingml/2006/main">
+            <a:extLst>
+              <a:ext uri="{FF2B5EF4-FFF2-40B4-BE49-F238E27FC236}">
+                <ns2:creationId id="{1786DD50-2954-4CFA-8861-259EB79A2EBD}"/>
+              </a:ext>
+            </a:extLst>
+          </p:cNvPr>
+          <p:cNvSpPr>
+            <a:spLocks noGrp="1"/>
+          </p:cNvSpPr>
+          <p:nvPr/>
+        </p:nvSpPr>
+        <p:spPr>
+          <a:xfrm>
             <a:off x="742950" y="4724400"/>
             <a:ext cx="10668000" cy="352425"/>
           </a:xfrm>
-          <a:prstGeom xmlns:a="http://schemas.openxmlformats.org/drawingml/2006/main" prst="rect">
-            <a:avLst/>
-          </a:prstGeom>
-          <a:noFill xmlns:a="http://schemas.openxmlformats.org/drawingml/2006/main"/>
-          <a:ln xmlns:a="http://schemas.openxmlformats.org/drawingml/2006/main" w="0">
-            <a:noFill/>
-          </a:ln>
-        </p:spPr>
-        <p:txBody>
-          <a:bodyPr xmlns:a="http://schemas.openxmlformats.org/drawingml/2006/main">
-            <a:noAutofit/>
-          </a:bodyPr>
-          <a:lstStyle xmlns:a="http://schemas.openxmlformats.org/drawingml/2006/main"/>
-          <a:p xmlns:a="http://schemas.openxmlformats.org/drawingml/2006/main">
+          <a:prstGeom prst="rect">
+            <a:avLst/>
+          </a:prstGeom>
+          <a:noFill/>
+          <a:ln w="0">
+            <a:noFill/>
+          </a:ln>
+        </p:spPr>
+        <p:txBody>
+          <a:bodyPr>
+            <a:noAutofit/>
+          </a:bodyPr>
+          <a:lstStyle/>
+          <a:p>
             <a:pPr>
               <a:defRPr sz="2100" b="1">
                 <a:solidFill>
@@ -9934,36 +9963,36 @@
       <p:sp>
         <p:nvSpPr>
           <p:cNvPr id="9" name="">
-            <a:extLst xmlns:a="http://schemas.openxmlformats.org/drawingml/2006/main">
-              <a:ext uri="{FF2B5EF4-FFF2-40B4-BE49-F238E27FC236}">
-                <a16:creationId xmlns:a16="http://schemas.microsoft.com/office/drawing/2014/main" id="{4E9191C7-92D3-4F86-86D1-7E81FA05BFD7}"/>
-              </a:ext>
-            </a:extLst>
-          </p:cNvPr>
-          <p:cNvSpPr>
-            <a:spLocks xmlns:a="http://schemas.openxmlformats.org/drawingml/2006/main" noGrp="1"/>
-          </p:cNvSpPr>
-          <p:nvPr/>
-        </p:nvSpPr>
-        <p:spPr>
-          <a:xfrm xmlns:a="http://schemas.openxmlformats.org/drawingml/2006/main">
+            <a:extLst>
+              <a:ext uri="{FF2B5EF4-FFF2-40B4-BE49-F238E27FC236}">
+                <ns2:creationId id="{4E9191C7-92D3-4F86-86D1-7E81FA05BFD7}"/>
+              </a:ext>
+            </a:extLst>
+          </p:cNvPr>
+          <p:cNvSpPr>
+            <a:spLocks noGrp="1"/>
+          </p:cNvSpPr>
+          <p:nvPr/>
+        </p:nvSpPr>
+        <p:spPr>
+          <a:xfrm>
             <a:off x="742950" y="5105400"/>
             <a:ext cx="10668000" cy="581025"/>
           </a:xfrm>
-          <a:prstGeom xmlns:a="http://schemas.openxmlformats.org/drawingml/2006/main" prst="rect">
-            <a:avLst/>
-          </a:prstGeom>
-          <a:noFill xmlns:a="http://schemas.openxmlformats.org/drawingml/2006/main"/>
-          <a:ln xmlns:a="http://schemas.openxmlformats.org/drawingml/2006/main" w="0">
-            <a:noFill/>
-          </a:ln>
-        </p:spPr>
-        <p:txBody>
-          <a:bodyPr xmlns:a="http://schemas.openxmlformats.org/drawingml/2006/main">
-            <a:noAutofit/>
-          </a:bodyPr>
-          <a:lstStyle xmlns:a="http://schemas.openxmlformats.org/drawingml/2006/main"/>
-          <a:p xmlns:a="http://schemas.openxmlformats.org/drawingml/2006/main">
+          <a:prstGeom prst="rect">
+            <a:avLst/>
+          </a:prstGeom>
+          <a:noFill/>
+          <a:ln w="0">
+            <a:noFill/>
+          </a:ln>
+        </p:spPr>
+        <p:txBody>
+          <a:bodyPr>
+            <a:noAutofit/>
+          </a:bodyPr>
+          <a:lstStyle/>
+          <a:p>
             <a:pPr>
               <a:defRPr sz="1800" b="0">
                 <a:solidFill>
@@ -9991,36 +10020,36 @@
       <p:sp>
         <p:nvSpPr>
           <p:cNvPr id="10" name="">
-            <a:extLst xmlns:a="http://schemas.openxmlformats.org/drawingml/2006/main">
-              <a:ext uri="{FF2B5EF4-FFF2-40B4-BE49-F238E27FC236}">
-                <a16:creationId xmlns:a16="http://schemas.microsoft.com/office/drawing/2014/main" id="{02536637-D589-4215-B902-8E3123DEA745}"/>
-              </a:ext>
-            </a:extLst>
-          </p:cNvPr>
-          <p:cNvSpPr>
-            <a:spLocks xmlns:a="http://schemas.openxmlformats.org/drawingml/2006/main" noGrp="1"/>
-          </p:cNvSpPr>
-          <p:nvPr/>
-        </p:nvSpPr>
-        <p:spPr>
-          <a:xfrm xmlns:a="http://schemas.openxmlformats.org/drawingml/2006/main">
+            <a:extLst>
+              <a:ext uri="{FF2B5EF4-FFF2-40B4-BE49-F238E27FC236}">
+                <ns2:creationId id="{02536637-D589-4215-B902-8E3123DEA745}"/>
+              </a:ext>
+            </a:extLst>
+          </p:cNvPr>
+          <p:cNvSpPr>
+            <a:spLocks noGrp="1"/>
+          </p:cNvSpPr>
+          <p:nvPr/>
+        </p:nvSpPr>
+        <p:spPr>
+          <a:xfrm>
             <a:off x="742950" y="6257925"/>
             <a:ext cx="10668000" cy="428625"/>
           </a:xfrm>
-          <a:prstGeom xmlns:a="http://schemas.openxmlformats.org/drawingml/2006/main" prst="rect">
-            <a:avLst/>
-          </a:prstGeom>
-          <a:noFill xmlns:a="http://schemas.openxmlformats.org/drawingml/2006/main"/>
-          <a:ln xmlns:a="http://schemas.openxmlformats.org/drawingml/2006/main" w="0">
-            <a:noFill/>
-          </a:ln>
-        </p:spPr>
-        <p:txBody>
-          <a:bodyPr xmlns:a="http://schemas.openxmlformats.org/drawingml/2006/main">
-            <a:noAutofit/>
-          </a:bodyPr>
-          <a:lstStyle xmlns:a="http://schemas.openxmlformats.org/drawingml/2006/main"/>
-          <a:p xmlns:a="http://schemas.openxmlformats.org/drawingml/2006/main">
+          <a:prstGeom prst="rect">
+            <a:avLst/>
+          </a:prstGeom>
+          <a:noFill/>
+          <a:ln w="0">
+            <a:noFill/>
+          </a:ln>
+        </p:spPr>
+        <p:txBody>
+          <a:bodyPr>
+            <a:noAutofit/>
+          </a:bodyPr>
+          <a:lstStyle/>
+          <a:p>
             <a:pPr>
               <a:defRPr sz="1575" b="0">
                 <a:solidFill>
@@ -10048,7 +10077,7 @@
     </p:spTree>
     <p:extLst>
       <p:ext uri="{BB962C8B-B14F-4D97-AF65-F5344CB8AC3E}">
-        <p14:creationId xmlns:p14="http://schemas.microsoft.com/office/powerpoint/2010/main" val="642569541"/>
+        <ns3:creationId val="642569541"/>
       </p:ext>
     </p:extLst>
   </p:cSld>
@@ -14140,7 +14169,7 @@
 </file>
 
 <file path=ppt/slides/slide9.xml><?xml version="1.0" encoding="utf-8"?>
-<p:sld xmlns:p="http://schemas.openxmlformats.org/presentationml/2006/main">
+<p:sld xmlns:a="http://schemas.openxmlformats.org/drawingml/2006/main" xmlns:ns2="http://schemas.microsoft.com/office/drawing/2014/main" xmlns:ns3="http://schemas.microsoft.com/office/powerpoint/2010/main" xmlns:p="http://schemas.openxmlformats.org/presentationml/2006/main">
   <p:cSld>
     <p:spTree>
       <p:nvGrpSpPr>
@@ -14149,41 +14178,41 @@
         <p:nvPr/>
       </p:nvGrpSpPr>
       <p:grpSpPr>
-        <a:xfrm xmlns:a="http://schemas.openxmlformats.org/drawingml/2006/main"/>
+        <a:xfrm/>
       </p:grpSpPr>
       <p:sp>
         <p:nvSpPr>
           <p:cNvPr id="13" name="">
-            <a:extLst xmlns:a="http://schemas.openxmlformats.org/drawingml/2006/main">
-              <a:ext uri="{FF2B5EF4-FFF2-40B4-BE49-F238E27FC236}">
-                <a16:creationId xmlns:a16="http://schemas.microsoft.com/office/drawing/2014/main" id="{812D9ADC-4857-4C62-9B3F-4552FB8BFD3D}"/>
-              </a:ext>
-            </a:extLst>
-          </p:cNvPr>
-          <p:cNvSpPr>
-            <a:spLocks xmlns:a="http://schemas.openxmlformats.org/drawingml/2006/main" noGrp="1"/>
-          </p:cNvSpPr>
-          <p:nvPr/>
-        </p:nvSpPr>
-        <p:spPr>
-          <a:xfrm xmlns:a="http://schemas.openxmlformats.org/drawingml/2006/main">
+            <a:extLst>
+              <a:ext uri="{FF2B5EF4-FFF2-40B4-BE49-F238E27FC236}">
+                <ns2:creationId id="{812D9ADC-4857-4C62-9B3F-4552FB8BFD3D}"/>
+              </a:ext>
+            </a:extLst>
+          </p:cNvPr>
+          <p:cNvSpPr>
+            <a:spLocks noGrp="1"/>
+          </p:cNvSpPr>
+          <p:nvPr/>
+        </p:nvSpPr>
+        <p:spPr>
+          <a:xfrm>
             <a:off x="666750" y="457200"/>
             <a:ext cx="10858500" cy="619125"/>
           </a:xfrm>
-          <a:prstGeom xmlns:a="http://schemas.openxmlformats.org/drawingml/2006/main" prst="rect">
-            <a:avLst/>
-          </a:prstGeom>
-          <a:noFill xmlns:a="http://schemas.openxmlformats.org/drawingml/2006/main"/>
-          <a:ln xmlns:a="http://schemas.openxmlformats.org/drawingml/2006/main" w="0">
-            <a:noFill/>
-          </a:ln>
-        </p:spPr>
-        <p:txBody>
-          <a:bodyPr xmlns:a="http://schemas.openxmlformats.org/drawingml/2006/main">
-            <a:noAutofit/>
-          </a:bodyPr>
-          <a:lstStyle xmlns:a="http://schemas.openxmlformats.org/drawingml/2006/main"/>
-          <a:p xmlns:a="http://schemas.openxmlformats.org/drawingml/2006/main">
+          <a:prstGeom prst="rect">
+            <a:avLst/>
+          </a:prstGeom>
+          <a:noFill/>
+          <a:ln w="0">
+            <a:noFill/>
+          </a:ln>
+        </p:spPr>
+        <p:txBody>
+          <a:bodyPr>
+            <a:noAutofit/>
+          </a:bodyPr>
+          <a:lstStyle/>
+          <a:p>
             <a:pPr>
               <a:buNone/>
               <a:defRPr sz="3000" b="1">
@@ -14204,7 +14233,7 @@
                 <a:ea typeface="Helvetica Neue"/>
                 <a:cs typeface="Helvetica Neue"/>
               </a:rPr>
-              <a:t>Correction contract and live-review boundary</a:t>
+              <a:t>Correction of a selected transcript phrase</a:t>
             </a:r>
           </a:p>
         </p:txBody>
@@ -14212,31 +14241,31 @@
       <p:sp>
         <p:nvSpPr>
           <p:cNvPr id="2" name="">
-            <a:extLst xmlns:a="http://schemas.openxmlformats.org/drawingml/2006/main">
-              <a:ext uri="{FF2B5EF4-FFF2-40B4-BE49-F238E27FC236}">
-                <a16:creationId xmlns:a16="http://schemas.microsoft.com/office/drawing/2014/main" id="{5BBA90F0-40A8-46B1-95C8-CC6A9811DAA7}"/>
-              </a:ext>
-            </a:extLst>
-          </p:cNvPr>
-          <p:cNvSpPr>
-            <a:spLocks xmlns:a="http://schemas.openxmlformats.org/drawingml/2006/main" noGrp="1"/>
-          </p:cNvSpPr>
-          <p:nvPr/>
-        </p:nvSpPr>
-        <p:spPr>
-          <a:xfrm xmlns:a="http://schemas.openxmlformats.org/drawingml/2006/main">
+            <a:extLst>
+              <a:ext uri="{FF2B5EF4-FFF2-40B4-BE49-F238E27FC236}">
+                <ns2:creationId id="{5BBA90F0-40A8-46B1-95C8-CC6A9811DAA7}"/>
+              </a:ext>
+            </a:extLst>
+          </p:cNvPr>
+          <p:cNvSpPr>
+            <a:spLocks noGrp="1"/>
+          </p:cNvSpPr>
+          <p:nvPr/>
+        </p:nvSpPr>
+        <p:spPr>
+          <a:xfrm>
             <a:off x="714375" y="1619250"/>
             <a:ext cx="3286125" cy="2809875"/>
           </a:xfrm>
-          <a:prstGeom xmlns:a="http://schemas.openxmlformats.org/drawingml/2006/main" prst="roundRect">
+          <a:prstGeom prst="roundRect">
             <a:avLst>
               <a:gd name="adj" fmla="val 2712"/>
             </a:avLst>
           </a:prstGeom>
-          <a:solidFill xmlns:a="http://schemas.openxmlformats.org/drawingml/2006/main">
+          <a:solidFill>
             <a:srgbClr val="F1F5F9"/>
           </a:solidFill>
-          <a:ln xmlns:a="http://schemas.openxmlformats.org/drawingml/2006/main" w="9525">
+          <a:ln w="9525">
             <a:solidFill>
               <a:srgbClr val="CBD5E1"/>
             </a:solidFill>
@@ -14246,36 +14275,36 @@
       <p:sp>
         <p:nvSpPr>
           <p:cNvPr id="3" name="">
-            <a:extLst xmlns:a="http://schemas.openxmlformats.org/drawingml/2006/main">
-              <a:ext uri="{FF2B5EF4-FFF2-40B4-BE49-F238E27FC236}">
-                <a16:creationId xmlns:a16="http://schemas.microsoft.com/office/drawing/2014/main" id="{0E373779-75B6-478A-AE79-19346E1D6F20}"/>
-              </a:ext>
-            </a:extLst>
-          </p:cNvPr>
-          <p:cNvSpPr>
-            <a:spLocks xmlns:a="http://schemas.openxmlformats.org/drawingml/2006/main" noGrp="1"/>
-          </p:cNvSpPr>
-          <p:nvPr/>
-        </p:nvSpPr>
-        <p:spPr>
-          <a:xfrm xmlns:a="http://schemas.openxmlformats.org/drawingml/2006/main">
+            <a:extLst>
+              <a:ext uri="{FF2B5EF4-FFF2-40B4-BE49-F238E27FC236}">
+                <ns2:creationId id="{0E373779-75B6-478A-AE79-19346E1D6F20}"/>
+              </a:ext>
+            </a:extLst>
+          </p:cNvPr>
+          <p:cNvSpPr>
+            <a:spLocks noGrp="1"/>
+          </p:cNvSpPr>
+          <p:nvPr/>
+        </p:nvSpPr>
+        <p:spPr>
+          <a:xfrm>
             <a:off x="885825" y="1790700"/>
             <a:ext cx="2943225" cy="400050"/>
           </a:xfrm>
-          <a:prstGeom xmlns:a="http://schemas.openxmlformats.org/drawingml/2006/main" prst="rect">
-            <a:avLst/>
-          </a:prstGeom>
-          <a:noFill xmlns:a="http://schemas.openxmlformats.org/drawingml/2006/main"/>
-          <a:ln xmlns:a="http://schemas.openxmlformats.org/drawingml/2006/main" w="0">
-            <a:noFill/>
-          </a:ln>
-        </p:spPr>
-        <p:txBody>
-          <a:bodyPr xmlns:a="http://schemas.openxmlformats.org/drawingml/2006/main">
-            <a:noAutofit/>
-          </a:bodyPr>
-          <a:lstStyle xmlns:a="http://schemas.openxmlformats.org/drawingml/2006/main"/>
-          <a:p xmlns:a="http://schemas.openxmlformats.org/drawingml/2006/main">
+          <a:prstGeom prst="rect">
+            <a:avLst/>
+          </a:prstGeom>
+          <a:noFill/>
+          <a:ln w="0">
+            <a:noFill/>
+          </a:ln>
+        </p:spPr>
+        <p:txBody>
+          <a:bodyPr>
+            <a:noAutofit/>
+          </a:bodyPr>
+          <a:lstStyle/>
+          <a:p>
             <a:pPr>
               <a:buNone/>
               <a:defRPr sz="1725" b="1">
@@ -14296,7 +14325,7 @@
                 <a:ea typeface="Helvetica Neue"/>
                 <a:cs typeface="Helvetica Neue"/>
               </a:rPr>
-              <a:t>Real Sejm CLI guard</a:t>
+              <a:t>1. Select and listen</a:t>
             </a:r>
           </a:p>
         </p:txBody>
@@ -14304,36 +14333,36 @@
       <p:sp>
         <p:nvSpPr>
           <p:cNvPr id="4" name="">
-            <a:extLst xmlns:a="http://schemas.openxmlformats.org/drawingml/2006/main">
-              <a:ext uri="{FF2B5EF4-FFF2-40B4-BE49-F238E27FC236}">
-                <a16:creationId xmlns:a16="http://schemas.microsoft.com/office/drawing/2014/main" id="{17B19ED1-209D-450D-A2C5-31658B681EB9}"/>
-              </a:ext>
-            </a:extLst>
-          </p:cNvPr>
-          <p:cNvSpPr>
-            <a:spLocks xmlns:a="http://schemas.openxmlformats.org/drawingml/2006/main" noGrp="1"/>
-          </p:cNvSpPr>
-          <p:nvPr/>
-        </p:nvSpPr>
-        <p:spPr>
-          <a:xfrm xmlns:a="http://schemas.openxmlformats.org/drawingml/2006/main">
+            <a:extLst>
+              <a:ext uri="{FF2B5EF4-FFF2-40B4-BE49-F238E27FC236}">
+                <ns2:creationId id="{17B19ED1-209D-450D-A2C5-31658B681EB9}"/>
+              </a:ext>
+            </a:extLst>
+          </p:cNvPr>
+          <p:cNvSpPr>
+            <a:spLocks noGrp="1"/>
+          </p:cNvSpPr>
+          <p:nvPr/>
+        </p:nvSpPr>
+        <p:spPr>
+          <a:xfrm>
             <a:off x="885825" y="2362200"/>
             <a:ext cx="2943225" cy="1905000"/>
           </a:xfrm>
-          <a:prstGeom xmlns:a="http://schemas.openxmlformats.org/drawingml/2006/main" prst="rect">
-            <a:avLst/>
-          </a:prstGeom>
-          <a:noFill xmlns:a="http://schemas.openxmlformats.org/drawingml/2006/main"/>
-          <a:ln xmlns:a="http://schemas.openxmlformats.org/drawingml/2006/main" w="0">
-            <a:noFill/>
-          </a:ln>
-        </p:spPr>
-        <p:txBody>
-          <a:bodyPr xmlns:a="http://schemas.openxmlformats.org/drawingml/2006/main">
-            <a:noAutofit/>
-          </a:bodyPr>
-          <a:lstStyle xmlns:a="http://schemas.openxmlformats.org/drawingml/2006/main"/>
-          <a:p xmlns:a="http://schemas.openxmlformats.org/drawingml/2006/main">
+          <a:prstGeom prst="rect">
+            <a:avLst/>
+          </a:prstGeom>
+          <a:noFill/>
+          <a:ln w="0">
+            <a:noFill/>
+          </a:ln>
+        </p:spPr>
+        <p:txBody>
+          <a:bodyPr>
+            <a:noAutofit/>
+          </a:bodyPr>
+          <a:lstStyle/>
+          <a:p>
             <a:pPr>
               <a:buNone/>
               <a:defRPr sz="1575" b="0">
@@ -14354,10 +14383,10 @@
                 <a:ea typeface="Helvetica Neue"/>
                 <a:cs typeface="Helvetica Neue"/>
               </a:rPr>
-              <a:t>Without --audio-reviewed yes:</a:t>
-            </a:r>
-          </a:p>
-          <a:p xmlns:a="http://schemas.openxmlformats.org/drawingml/2006/main">
+              <a:t>Select phrase; Correct selection.</a:t>
+            </a:r>
+          </a:p>
+          <a:p>
             <a:pPr>
               <a:buNone/>
               <a:defRPr sz="1575" b="0">
@@ -14378,10 +14407,10 @@
                 <a:ea typeface="Helvetica Neue"/>
                 <a:cs typeface="Helvetica Neue"/>
               </a:rPr>
-              <a:t>exit 2.</a:t>
-            </a:r>
-          </a:p>
-          <a:p xmlns:a="http://schemas.openxmlformats.org/drawingml/2006/main">
+              <a:t>Set audio before and after.</a:t>
+            </a:r>
+          </a:p>
+          <a:p>
             <a:pPr>
               <a:buNone/>
               <a:defRPr sz="1575" b="0">
@@ -14402,10 +14431,10 @@
                 <a:ea typeface="Helvetica Neue"/>
                 <a:cs typeface="Helvetica Neue"/>
               </a:rPr>
-              <a:t>Record SHA-256 unchanged.</a:t>
-            </a:r>
-          </a:p>
-          <a:p xmlns:a="http://schemas.openxmlformats.org/drawingml/2006/main">
+              <a:t>Play selection with context.</a:t>
+            </a:r>
+          </a:p>
+          <a:p>
             <a:pPr>
               <a:buNone/>
               <a:defRPr sz="1575" b="0">
@@ -14426,7 +14455,31 @@
                 <a:ea typeface="Helvetica Neue"/>
                 <a:cs typeface="Helvetica Neue"/>
               </a:rPr>
-              <a:t>No correction saved.</a:t>
+              <a:t>Use slider to inspect silence.</a:t>
+            </a:r>
+          </a:p>
+          <a:p>
+            <a:pPr>
+              <a:buNone/>
+              <a:defRPr sz="1575" b="0">
+                <a:solidFill>
+                  <a:srgbClr val="475569"/>
+                </a:solidFill>
+                <a:latin typeface="Helvetica Neue"/>
+                <a:ea typeface="Helvetica Neue"/>
+                <a:cs typeface="Helvetica Neue"/>
+              </a:defRPr>
+            </a:pPr>
+            <a:r>
+              <a:rPr sz="1575" b="0">
+                <a:solidFill>
+                  <a:srgbClr val="475569"/>
+                </a:solidFill>
+                <a:latin typeface="Helvetica Neue"/>
+                <a:ea typeface="Helvetica Neue"/>
+                <a:cs typeface="Helvetica Neue"/>
+              </a:rPr>
+              <a:t>Check the recorded words.</a:t>
             </a:r>
           </a:p>
         </p:txBody>
@@ -14434,31 +14487,31 @@
       <p:sp>
         <p:nvSpPr>
           <p:cNvPr id="5" name="">
-            <a:extLst xmlns:a="http://schemas.openxmlformats.org/drawingml/2006/main">
-              <a:ext uri="{FF2B5EF4-FFF2-40B4-BE49-F238E27FC236}">
-                <a16:creationId xmlns:a16="http://schemas.microsoft.com/office/drawing/2014/main" id="{42BC24E5-3B52-4C63-9962-5ED605FA31A2}"/>
-              </a:ext>
-            </a:extLst>
-          </p:cNvPr>
-          <p:cNvSpPr>
-            <a:spLocks xmlns:a="http://schemas.openxmlformats.org/drawingml/2006/main" noGrp="1"/>
-          </p:cNvSpPr>
-          <p:nvPr/>
-        </p:nvSpPr>
-        <p:spPr>
-          <a:xfrm xmlns:a="http://schemas.openxmlformats.org/drawingml/2006/main">
+            <a:extLst>
+              <a:ext uri="{FF2B5EF4-FFF2-40B4-BE49-F238E27FC236}">
+                <ns2:creationId id="{42BC24E5-3B52-4C63-9962-5ED605FA31A2}"/>
+              </a:ext>
+            </a:extLst>
+          </p:cNvPr>
+          <p:cNvSpPr>
+            <a:spLocks noGrp="1"/>
+          </p:cNvSpPr>
+          <p:nvPr/>
+        </p:nvSpPr>
+        <p:spPr>
+          <a:xfrm>
             <a:off x="4448175" y="1619250"/>
             <a:ext cx="3286125" cy="2809875"/>
           </a:xfrm>
-          <a:prstGeom xmlns:a="http://schemas.openxmlformats.org/drawingml/2006/main" prst="roundRect">
+          <a:prstGeom prst="roundRect">
             <a:avLst>
               <a:gd name="adj" fmla="val 2712"/>
             </a:avLst>
           </a:prstGeom>
-          <a:solidFill xmlns:a="http://schemas.openxmlformats.org/drawingml/2006/main">
+          <a:solidFill>
             <a:srgbClr val="EFF6FF"/>
           </a:solidFill>
-          <a:ln xmlns:a="http://schemas.openxmlformats.org/drawingml/2006/main" w="9525">
+          <a:ln w="9525">
             <a:solidFill>
               <a:srgbClr val="CBD5E1"/>
             </a:solidFill>
@@ -14468,36 +14521,36 @@
       <p:sp>
         <p:nvSpPr>
           <p:cNvPr id="6" name="">
-            <a:extLst xmlns:a="http://schemas.openxmlformats.org/drawingml/2006/main">
-              <a:ext uri="{FF2B5EF4-FFF2-40B4-BE49-F238E27FC236}">
-                <a16:creationId xmlns:a16="http://schemas.microsoft.com/office/drawing/2014/main" id="{4E3B9CE8-7E6E-42DE-ACF8-7EE6C898AF92}"/>
-              </a:ext>
-            </a:extLst>
-          </p:cNvPr>
-          <p:cNvSpPr>
-            <a:spLocks xmlns:a="http://schemas.openxmlformats.org/drawingml/2006/main" noGrp="1"/>
-          </p:cNvSpPr>
-          <p:nvPr/>
-        </p:nvSpPr>
-        <p:spPr>
-          <a:xfrm xmlns:a="http://schemas.openxmlformats.org/drawingml/2006/main">
+            <a:extLst>
+              <a:ext uri="{FF2B5EF4-FFF2-40B4-BE49-F238E27FC236}">
+                <ns2:creationId id="{4E3B9CE8-7E6E-42DE-ACF8-7EE6C898AF92}"/>
+              </a:ext>
+            </a:extLst>
+          </p:cNvPr>
+          <p:cNvSpPr>
+            <a:spLocks noGrp="1"/>
+          </p:cNvSpPr>
+          <p:nvPr/>
+        </p:nvSpPr>
+        <p:spPr>
+          <a:xfrm>
             <a:off x="4619625" y="1790700"/>
             <a:ext cx="2943225" cy="400050"/>
           </a:xfrm>
-          <a:prstGeom xmlns:a="http://schemas.openxmlformats.org/drawingml/2006/main" prst="rect">
-            <a:avLst/>
-          </a:prstGeom>
-          <a:noFill xmlns:a="http://schemas.openxmlformats.org/drawingml/2006/main"/>
-          <a:ln xmlns:a="http://schemas.openxmlformats.org/drawingml/2006/main" w="0">
-            <a:noFill/>
-          </a:ln>
-        </p:spPr>
-        <p:txBody>
-          <a:bodyPr xmlns:a="http://schemas.openxmlformats.org/drawingml/2006/main">
-            <a:noAutofit/>
-          </a:bodyPr>
-          <a:lstStyle xmlns:a="http://schemas.openxmlformats.org/drawingml/2006/main"/>
-          <a:p xmlns:a="http://schemas.openxmlformats.org/drawingml/2006/main">
+          <a:prstGeom prst="rect">
+            <a:avLst/>
+          </a:prstGeom>
+          <a:noFill/>
+          <a:ln w="0">
+            <a:noFill/>
+          </a:ln>
+        </p:spPr>
+        <p:txBody>
+          <a:bodyPr>
+            <a:noAutofit/>
+          </a:bodyPr>
+          <a:lstStyle/>
+          <a:p>
             <a:pPr>
               <a:buNone/>
               <a:defRPr sz="1725" b="1">
@@ -14518,7 +14571,7 @@
                 <a:ea typeface="Helvetica Neue"/>
                 <a:cs typeface="Helvetica Neue"/>
               </a:rPr>
-              <a:t>Controlled test only</a:t>
+              <a:t>2. Save the correction</a:t>
             </a:r>
           </a:p>
         </p:txBody>
@@ -14526,36 +14579,36 @@
       <p:sp>
         <p:nvSpPr>
           <p:cNvPr id="7" name="">
-            <a:extLst xmlns:a="http://schemas.openxmlformats.org/drawingml/2006/main">
-              <a:ext uri="{FF2B5EF4-FFF2-40B4-BE49-F238E27FC236}">
-                <a16:creationId xmlns:a16="http://schemas.microsoft.com/office/drawing/2014/main" id="{480F2E3F-9AE9-4B28-B6AF-C6A1137C9FF4}"/>
-              </a:ext>
-            </a:extLst>
-          </p:cNvPr>
-          <p:cNvSpPr>
-            <a:spLocks xmlns:a="http://schemas.openxmlformats.org/drawingml/2006/main" noGrp="1"/>
-          </p:cNvSpPr>
-          <p:nvPr/>
-        </p:nvSpPr>
-        <p:spPr>
-          <a:xfrm xmlns:a="http://schemas.openxmlformats.org/drawingml/2006/main">
+            <a:extLst>
+              <a:ext uri="{FF2B5EF4-FFF2-40B4-BE49-F238E27FC236}">
+                <ns2:creationId id="{480F2E3F-9AE9-4B28-B6AF-C6A1137C9FF4}"/>
+              </a:ext>
+            </a:extLst>
+          </p:cNvPr>
+          <p:cNvSpPr>
+            <a:spLocks noGrp="1"/>
+          </p:cNvSpPr>
+          <p:nvPr/>
+        </p:nvSpPr>
+        <p:spPr>
+          <a:xfrm>
             <a:off x="4619625" y="2362200"/>
             <a:ext cx="2943225" cy="1905000"/>
           </a:xfrm>
-          <a:prstGeom xmlns:a="http://schemas.openxmlformats.org/drawingml/2006/main" prst="rect">
-            <a:avLst/>
-          </a:prstGeom>
-          <a:noFill xmlns:a="http://schemas.openxmlformats.org/drawingml/2006/main"/>
-          <a:ln xmlns:a="http://schemas.openxmlformats.org/drawingml/2006/main" w="0">
-            <a:noFill/>
-          </a:ln>
-        </p:spPr>
-        <p:txBody>
-          <a:bodyPr xmlns:a="http://schemas.openxmlformats.org/drawingml/2006/main">
-            <a:noAutofit/>
-          </a:bodyPr>
-          <a:lstStyle xmlns:a="http://schemas.openxmlformats.org/drawingml/2006/main"/>
-          <a:p xmlns:a="http://schemas.openxmlformats.org/drawingml/2006/main">
+          <a:prstGeom prst="rect">
+            <a:avLst/>
+          </a:prstGeom>
+          <a:noFill/>
+          <a:ln w="0">
+            <a:noFill/>
+          </a:ln>
+        </p:spPr>
+        <p:txBody>
+          <a:bodyPr>
+            <a:noAutofit/>
+          </a:bodyPr>
+          <a:lstStyle/>
+          <a:p>
             <a:pPr>
               <a:buNone/>
               <a:defRPr sz="1575" b="0">
@@ -14576,10 +14629,10 @@
                 <a:ea typeface="Helvetica Neue"/>
                 <a:cs typeface="Helvetica Neue"/>
               </a:rPr>
-              <a:t>Raw: “thirty five million”</a:t>
-            </a:r>
-          </a:p>
-          <a:p xmlns:a="http://schemas.openxmlformats.org/drawingml/2006/main">
+              <a:t>Edit the selected phrase.</a:t>
+            </a:r>
+          </a:p>
+          <a:p>
             <a:pPr>
               <a:buNone/>
               <a:defRPr sz="1575" b="0">
@@ -14600,10 +14653,10 @@
                 <a:ea typeface="Helvetica Neue"/>
                 <a:cs typeface="Helvetica Neue"/>
               </a:rPr>
-              <a:t>Reading: “thirty five billion”</a:t>
-            </a:r>
-          </a:p>
-          <a:p xmlns:a="http://schemas.openxmlformats.org/drawingml/2006/main">
+              <a:t>Confirm that you listened.</a:t>
+            </a:r>
+          </a:p>
+          <a:p>
             <a:pPr>
               <a:buNone/>
               <a:defRPr sz="1575" b="0">
@@ -14624,10 +14677,10 @@
                 <a:ea typeface="Helvetica Neue"/>
                 <a:cs typeface="Helvetica Neue"/>
               </a:rPr>
-              <a:t>Restore: original words</a:t>
-            </a:r>
-          </a:p>
-          <a:p xmlns:a="http://schemas.openxmlformats.org/drawingml/2006/main">
+              <a:t>Click Save correction.</a:t>
+            </a:r>
+          </a:p>
+          <a:p>
             <a:pPr>
               <a:buNone/>
               <a:defRPr sz="1575" b="0">
@@ -14648,7 +14701,31 @@
                 <a:ea typeface="Helvetica Neue"/>
                 <a:cs typeface="Helvetica Neue"/>
               </a:rPr>
-              <a:t>Two audit entries; raw retained.</a:t>
+              <a:t>Surrounding words stay.</a:t>
+            </a:r>
+          </a:p>
+          <a:p>
+            <a:pPr>
+              <a:buNone/>
+              <a:defRPr sz="1575" b="0">
+                <a:solidFill>
+                  <a:srgbClr val="475569"/>
+                </a:solidFill>
+                <a:latin typeface="Helvetica Neue"/>
+                <a:ea typeface="Helvetica Neue"/>
+                <a:cs typeface="Helvetica Neue"/>
+              </a:defRPr>
+            </a:pPr>
+            <a:r>
+              <a:rPr sz="1575" b="0">
+                <a:solidFill>
+                  <a:srgbClr val="475569"/>
+                </a:solidFill>
+                <a:latin typeface="Helvetica Neue"/>
+                <a:ea typeface="Helvetica Neue"/>
+                <a:cs typeface="Helvetica Neue"/>
+              </a:rPr>
+              <a:t>Old draft minutes clear.</a:t>
             </a:r>
           </a:p>
         </p:txBody>
@@ -14656,31 +14733,31 @@
       <p:sp>
         <p:nvSpPr>
           <p:cNvPr id="8" name="">
-            <a:extLst xmlns:a="http://schemas.openxmlformats.org/drawingml/2006/main">
-              <a:ext uri="{FF2B5EF4-FFF2-40B4-BE49-F238E27FC236}">
-                <a16:creationId xmlns:a16="http://schemas.microsoft.com/office/drawing/2014/main" id="{DC632E1E-F549-4971-B0CB-BF7AF06A443E}"/>
-              </a:ext>
-            </a:extLst>
-          </p:cNvPr>
-          <p:cNvSpPr>
-            <a:spLocks xmlns:a="http://schemas.openxmlformats.org/drawingml/2006/main" noGrp="1"/>
-          </p:cNvSpPr>
-          <p:nvPr/>
-        </p:nvSpPr>
-        <p:spPr>
-          <a:xfrm xmlns:a="http://schemas.openxmlformats.org/drawingml/2006/main">
+            <a:extLst>
+              <a:ext uri="{FF2B5EF4-FFF2-40B4-BE49-F238E27FC236}">
+                <ns2:creationId id="{DC632E1E-F549-4971-B0CB-BF7AF06A443E}"/>
+              </a:ext>
+            </a:extLst>
+          </p:cNvPr>
+          <p:cNvSpPr>
+            <a:spLocks noGrp="1"/>
+          </p:cNvSpPr>
+          <p:nvPr/>
+        </p:nvSpPr>
+        <p:spPr>
+          <a:xfrm>
             <a:off x="8181975" y="1619250"/>
             <a:ext cx="3286125" cy="2809875"/>
           </a:xfrm>
-          <a:prstGeom xmlns:a="http://schemas.openxmlformats.org/drawingml/2006/main" prst="roundRect">
+          <a:prstGeom prst="roundRect">
             <a:avLst>
               <a:gd name="adj" fmla="val 2712"/>
             </a:avLst>
           </a:prstGeom>
-          <a:solidFill xmlns:a="http://schemas.openxmlformats.org/drawingml/2006/main">
+          <a:solidFill>
             <a:srgbClr val="FFF7ED"/>
           </a:solidFill>
-          <a:ln xmlns:a="http://schemas.openxmlformats.org/drawingml/2006/main" w="9525">
+          <a:ln w="9525">
             <a:solidFill>
               <a:srgbClr val="CBD5E1"/>
             </a:solidFill>
@@ -14690,36 +14767,36 @@
       <p:sp>
         <p:nvSpPr>
           <p:cNvPr id="9" name="">
-            <a:extLst xmlns:a="http://schemas.openxmlformats.org/drawingml/2006/main">
-              <a:ext uri="{FF2B5EF4-FFF2-40B4-BE49-F238E27FC236}">
-                <a16:creationId xmlns:a16="http://schemas.microsoft.com/office/drawing/2014/main" id="{C2B6BD40-ABEC-40BA-8AA9-609D8F65390B}"/>
-              </a:ext>
-            </a:extLst>
-          </p:cNvPr>
-          <p:cNvSpPr>
-            <a:spLocks xmlns:a="http://schemas.openxmlformats.org/drawingml/2006/main" noGrp="1"/>
-          </p:cNvSpPr>
-          <p:nvPr/>
-        </p:nvSpPr>
-        <p:spPr>
-          <a:xfrm xmlns:a="http://schemas.openxmlformats.org/drawingml/2006/main">
+            <a:extLst>
+              <a:ext uri="{FF2B5EF4-FFF2-40B4-BE49-F238E27FC236}">
+                <ns2:creationId id="{C2B6BD40-ABEC-40BA-8AA9-609D8F65390B}"/>
+              </a:ext>
+            </a:extLst>
+          </p:cNvPr>
+          <p:cNvSpPr>
+            <a:spLocks noGrp="1"/>
+          </p:cNvSpPr>
+          <p:nvPr/>
+        </p:nvSpPr>
+        <p:spPr>
+          <a:xfrm>
             <a:off x="8353425" y="1790700"/>
             <a:ext cx="2943225" cy="400050"/>
           </a:xfrm>
-          <a:prstGeom xmlns:a="http://schemas.openxmlformats.org/drawingml/2006/main" prst="rect">
-            <a:avLst/>
-          </a:prstGeom>
-          <a:noFill xmlns:a="http://schemas.openxmlformats.org/drawingml/2006/main"/>
-          <a:ln xmlns:a="http://schemas.openxmlformats.org/drawingml/2006/main" w="0">
-            <a:noFill/>
-          </a:ln>
-        </p:spPr>
-        <p:txBody>
-          <a:bodyPr xmlns:a="http://schemas.openxmlformats.org/drawingml/2006/main">
-            <a:noAutofit/>
-          </a:bodyPr>
-          <a:lstStyle xmlns:a="http://schemas.openxmlformats.org/drawingml/2006/main"/>
-          <a:p xmlns:a="http://schemas.openxmlformats.org/drawingml/2006/main">
+          <a:prstGeom prst="rect">
+            <a:avLst/>
+          </a:prstGeom>
+          <a:noFill/>
+          <a:ln w="0">
+            <a:noFill/>
+          </a:ln>
+        </p:spPr>
+        <p:txBody>
+          <a:bodyPr>
+            <a:noAutofit/>
+          </a:bodyPr>
+          <a:lstStyle/>
+          <a:p>
             <a:pPr>
               <a:buNone/>
               <a:defRPr sz="1725" b="1">
@@ -14740,7 +14817,7 @@
                 <a:ea typeface="Helvetica Neue"/>
                 <a:cs typeface="Helvetica Neue"/>
               </a:rPr>
-              <a:t>Pending with operator</a:t>
+              <a:t>3. Restore if needed</a:t>
             </a:r>
           </a:p>
         </p:txBody>
@@ -14748,36 +14825,36 @@
       <p:sp>
         <p:nvSpPr>
           <p:cNvPr id="10" name="">
-            <a:extLst xmlns:a="http://schemas.openxmlformats.org/drawingml/2006/main">
-              <a:ext uri="{FF2B5EF4-FFF2-40B4-BE49-F238E27FC236}">
-                <a16:creationId xmlns:a16="http://schemas.microsoft.com/office/drawing/2014/main" id="{BDE92EAF-0BE8-4CB4-895C-EE34ADF5EDA7}"/>
-              </a:ext>
-            </a:extLst>
-          </p:cNvPr>
-          <p:cNvSpPr>
-            <a:spLocks xmlns:a="http://schemas.openxmlformats.org/drawingml/2006/main" noGrp="1"/>
-          </p:cNvSpPr>
-          <p:nvPr/>
-        </p:nvSpPr>
-        <p:spPr>
-          <a:xfrm xmlns:a="http://schemas.openxmlformats.org/drawingml/2006/main">
+            <a:extLst>
+              <a:ext uri="{FF2B5EF4-FFF2-40B4-BE49-F238E27FC236}">
+                <ns2:creationId id="{BDE92EAF-0BE8-4CB4-895C-EE34ADF5EDA7}"/>
+              </a:ext>
+            </a:extLst>
+          </p:cNvPr>
+          <p:cNvSpPr>
+            <a:spLocks noGrp="1"/>
+          </p:cNvSpPr>
+          <p:nvPr/>
+        </p:nvSpPr>
+        <p:spPr>
+          <a:xfrm>
             <a:off x="8353425" y="2362200"/>
             <a:ext cx="2943225" cy="1905000"/>
           </a:xfrm>
-          <a:prstGeom xmlns:a="http://schemas.openxmlformats.org/drawingml/2006/main" prst="rect">
-            <a:avLst/>
-          </a:prstGeom>
-          <a:noFill xmlns:a="http://schemas.openxmlformats.org/drawingml/2006/main"/>
-          <a:ln xmlns:a="http://schemas.openxmlformats.org/drawingml/2006/main" w="0">
-            <a:noFill/>
-          </a:ln>
-        </p:spPr>
-        <p:txBody>
-          <a:bodyPr xmlns:a="http://schemas.openxmlformats.org/drawingml/2006/main">
-            <a:noAutofit/>
-          </a:bodyPr>
-          <a:lstStyle xmlns:a="http://schemas.openxmlformats.org/drawingml/2006/main"/>
-          <a:p xmlns:a="http://schemas.openxmlformats.org/drawingml/2006/main">
+          <a:prstGeom prst="rect">
+            <a:avLst/>
+          </a:prstGeom>
+          <a:noFill/>
+          <a:ln w="0">
+            <a:noFill/>
+          </a:ln>
+        </p:spPr>
+        <p:txBody>
+          <a:bodyPr>
+            <a:noAutofit/>
+          </a:bodyPr>
+          <a:lstStyle/>
+          <a:p>
             <a:pPr>
               <a:buNone/>
               <a:defRPr sz="1575" b="0">
@@ -14798,10 +14875,10 @@
                 <a:ea typeface="Helvetica Neue"/>
                 <a:cs typeface="Helvetica Neue"/>
               </a:rPr>
-              <a:t>Play source range and listen.</a:t>
-            </a:r>
-          </a:p>
-          <a:p xmlns:a="http://schemas.openxmlformats.org/drawingml/2006/main">
+              <a:t>Select the saved replacement.</a:t>
+            </a:r>
+          </a:p>
+          <a:p>
             <a:pPr>
               <a:buNone/>
               <a:defRPr sz="1575" b="0">
@@ -14822,10 +14899,10 @@
                 <a:ea typeface="Helvetica Neue"/>
                 <a:cs typeface="Helvetica Neue"/>
               </a:rPr>
-              <a:t>Correct an actual word.</a:t>
-            </a:r>
-          </a:p>
-          <a:p xmlns:a="http://schemas.openxmlformats.org/drawingml/2006/main">
+              <a:t>Use Restore original.</a:t>
+            </a:r>
+          </a:p>
+          <a:p>
             <a:pPr>
               <a:buNone/>
               <a:defRPr sz="1575" b="0">
@@ -14846,10 +14923,10 @@
                 <a:ea typeface="Helvetica Neue"/>
                 <a:cs typeface="Helvetica Neue"/>
               </a:rPr>
-              <a:t>Replay, restore if needed.</a:t>
-            </a:r>
-          </a:p>
-          <a:p xmlns:a="http://schemas.openxmlformats.org/drawingml/2006/main">
+              <a:t>Confirm after listening.</a:t>
+            </a:r>
+          </a:p>
+          <a:p>
             <a:pPr>
               <a:buNone/>
               <a:defRPr sz="1575" b="0">
@@ -14870,7 +14947,7 @@
                 <a:ea typeface="Helvetica Neue"/>
                 <a:cs typeface="Helvetica Neue"/>
               </a:rPr>
-              <a:t>Verify a speaker before naming.</a:t>
+              <a:t>Source and history remain.</a:t>
             </a:r>
           </a:p>
         </p:txBody>
@@ -14878,39 +14955,39 @@
       <p:sp>
         <p:nvSpPr>
           <p:cNvPr id="11" name="">
-            <a:extLst xmlns:a="http://schemas.openxmlformats.org/drawingml/2006/main">
-              <a:ext uri="{FF2B5EF4-FFF2-40B4-BE49-F238E27FC236}">
-                <a16:creationId xmlns:a16="http://schemas.microsoft.com/office/drawing/2014/main" id="{C88BBC04-3FC1-4A47-9472-D32B5E148531}"/>
-              </a:ext>
-            </a:extLst>
-          </p:cNvPr>
-          <p:cNvSpPr>
-            <a:spLocks xmlns:a="http://schemas.openxmlformats.org/drawingml/2006/main" noGrp="1"/>
-          </p:cNvSpPr>
-          <p:nvPr/>
-        </p:nvSpPr>
-        <p:spPr>
-          <a:xfrm xmlns:a="http://schemas.openxmlformats.org/drawingml/2006/main">
+            <a:extLst>
+              <a:ext uri="{FF2B5EF4-FFF2-40B4-BE49-F238E27FC236}">
+                <ns2:creationId id="{C88BBC04-3FC1-4A47-9472-D32B5E148531}"/>
+              </a:ext>
+            </a:extLst>
+          </p:cNvPr>
+          <p:cNvSpPr>
+            <a:spLocks noGrp="1"/>
+          </p:cNvSpPr>
+          <p:nvPr/>
+        </p:nvSpPr>
+        <p:spPr>
+          <a:xfrm>
             <a:off x="714375" y="4953000"/>
             <a:ext cx="10572750" cy="952500"/>
           </a:xfrm>
-          <a:prstGeom xmlns:a="http://schemas.openxmlformats.org/drawingml/2006/main" prst="rect">
-            <a:avLst/>
-          </a:prstGeom>
-          <a:noFill xmlns:a="http://schemas.openxmlformats.org/drawingml/2006/main"/>
-          <a:ln xmlns:a="http://schemas.openxmlformats.org/drawingml/2006/main" w="0">
-            <a:noFill/>
-          </a:ln>
-        </p:spPr>
-        <p:txBody>
-          <a:bodyPr xmlns:a="http://schemas.openxmlformats.org/drawingml/2006/main">
-            <a:noAutofit/>
-          </a:bodyPr>
-          <a:lstStyle xmlns:a="http://schemas.openxmlformats.org/drawingml/2006/main"/>
-          <a:p xmlns:a="http://schemas.openxmlformats.org/drawingml/2006/main">
+          <a:prstGeom prst="rect">
+            <a:avLst/>
+          </a:prstGeom>
+          <a:noFill/>
+          <a:ln w="0">
+            <a:noFill/>
+          </a:ln>
+        </p:spPr>
+        <p:txBody>
+          <a:bodyPr>
+            <a:noAutofit/>
+          </a:bodyPr>
+          <a:lstStyle/>
+          <a:p>
             <a:pPr>
               <a:buNone/>
-              <a:defRPr sz="1575" b="1">
+              <a:defRPr sz="1500" b="0">
                 <a:solidFill>
                   <a:srgbClr val="142735"/>
                 </a:solidFill>
@@ -14920,7 +14997,7 @@
               </a:defRPr>
             </a:pPr>
             <a:r>
-              <a:rPr sz="1575" b="1">
+              <a:rPr sz="1500" b="0">
                 <a:solidFill>
                   <a:srgbClr val="142735"/>
                 </a:solidFill>
@@ -14928,7 +15005,79 @@
                 <a:ea typeface="Helvetica Neue"/>
                 <a:cs typeface="Helvetica Neue"/>
               </a:rPr>
-              <a:t>Unit, CLI/store and speaker-edit tests pass. The player launched, but seek and bounded playback could not be observed in this rehearsal.</a:t>
+              <a:t>CLI for one source part after listening:</a:t>
+            </a:r>
+          </a:p>
+          <a:p>
+            <a:pPr>
+              <a:buNone/>
+              <a:defRPr sz="1500" b="0">
+                <a:solidFill>
+                  <a:srgbClr val="142735"/>
+                </a:solidFill>
+                <a:latin typeface="Helvetica Neue"/>
+                <a:ea typeface="Helvetica Neue"/>
+                <a:cs typeface="Helvetica Neue"/>
+              </a:defRPr>
+            </a:pPr>
+            <a:r>
+              <a:rPr sz="1500" b="0">
+                <a:solidFill>
+                  <a:srgbClr val="142735"/>
+                </a:solidFill>
+                <a:latin typeface="Helvetica Neue"/>
+                <a:ea typeface="Helvetica Neue"/>
+                <a:cs typeface="Helvetica Neue"/>
+              </a:rPr>
+              <a:t>swift run meeting-summarizer transcribe correct \</a:t>
+            </a:r>
+          </a:p>
+          <a:p>
+            <a:pPr>
+              <a:buNone/>
+              <a:defRPr sz="1500" b="0">
+                <a:solidFill>
+                  <a:srgbClr val="142735"/>
+                </a:solidFill>
+                <a:latin typeface="Helvetica Neue"/>
+                <a:ea typeface="Helvetica Neue"/>
+                <a:cs typeface="Helvetica Neue"/>
+              </a:defRPr>
+            </a:pPr>
+            <a:r>
+              <a:rPr sz="1500" b="0">
+                <a:solidFill>
+                  <a:srgbClr val="142735"/>
+                </a:solidFill>
+                <a:latin typeface="Helvetica Neue"/>
+                <a:ea typeface="Helvetica Neue"/>
+                <a:cs typeface="Helvetica Neue"/>
+              </a:rPr>
+              <a:t>  "$polish_id" "$segment_id" "$corrected_text" \</a:t>
+            </a:r>
+          </a:p>
+          <a:p>
+            <a:pPr>
+              <a:buNone/>
+              <a:defRPr sz="1500" b="0">
+                <a:solidFill>
+                  <a:srgbClr val="142735"/>
+                </a:solidFill>
+                <a:latin typeface="Helvetica Neue"/>
+                <a:ea typeface="Helvetica Neue"/>
+                <a:cs typeface="Helvetica Neue"/>
+              </a:defRPr>
+            </a:pPr>
+            <a:r>
+              <a:rPr sz="1500" b="0">
+                <a:solidFill>
+                  <a:srgbClr val="142735"/>
+                </a:solidFill>
+                <a:latin typeface="Helvetica Neue"/>
+                <a:ea typeface="Helvetica Neue"/>
+                <a:cs typeface="Helvetica Neue"/>
+              </a:rPr>
+              <a:t>  --audio-reviewed yes --store "$store_dir"</a:t>
             </a:r>
           </a:p>
         </p:txBody>
@@ -14936,36 +15085,36 @@
       <p:sp>
         <p:nvSpPr>
           <p:cNvPr id="12" name="">
-            <a:extLst xmlns:a="http://schemas.openxmlformats.org/drawingml/2006/main">
-              <a:ext uri="{FF2B5EF4-FFF2-40B4-BE49-F238E27FC236}">
-                <a16:creationId xmlns:a16="http://schemas.microsoft.com/office/drawing/2014/main" id="{284D9990-0E7D-4D7C-B320-A876993966C6}"/>
-              </a:ext>
-            </a:extLst>
-          </p:cNvPr>
-          <p:cNvSpPr>
-            <a:spLocks xmlns:a="http://schemas.openxmlformats.org/drawingml/2006/main" noGrp="1"/>
-          </p:cNvSpPr>
-          <p:nvPr/>
-        </p:nvSpPr>
-        <p:spPr>
-          <a:xfrm xmlns:a="http://schemas.openxmlformats.org/drawingml/2006/main">
+            <a:extLst>
+              <a:ext uri="{FF2B5EF4-FFF2-40B4-BE49-F238E27FC236}">
+                <ns2:creationId id="{284D9990-0E7D-4D7C-B320-A876993966C6}"/>
+              </a:ext>
+            </a:extLst>
+          </p:cNvPr>
+          <p:cNvSpPr>
+            <a:spLocks noGrp="1"/>
+          </p:cNvSpPr>
+          <p:nvPr/>
+        </p:nvSpPr>
+        <p:spPr>
+          <a:xfrm>
             <a:off x="714375" y="6124575"/>
             <a:ext cx="10572750" cy="247650"/>
           </a:xfrm>
-          <a:prstGeom xmlns:a="http://schemas.openxmlformats.org/drawingml/2006/main" prst="rect">
-            <a:avLst/>
-          </a:prstGeom>
-          <a:noFill xmlns:a="http://schemas.openxmlformats.org/drawingml/2006/main"/>
-          <a:ln xmlns:a="http://schemas.openxmlformats.org/drawingml/2006/main" w="0">
-            <a:noFill/>
-          </a:ln>
-        </p:spPr>
-        <p:txBody>
-          <a:bodyPr xmlns:a="http://schemas.openxmlformats.org/drawingml/2006/main">
-            <a:noAutofit/>
-          </a:bodyPr>
-          <a:lstStyle xmlns:a="http://schemas.openxmlformats.org/drawingml/2006/main"/>
-          <a:p xmlns:a="http://schemas.openxmlformats.org/drawingml/2006/main">
+          <a:prstGeom prst="rect">
+            <a:avLst/>
+          </a:prstGeom>
+          <a:noFill/>
+          <a:ln w="0">
+            <a:noFill/>
+          </a:ln>
+        </p:spPr>
+        <p:txBody>
+          <a:bodyPr>
+            <a:noAutofit/>
+          </a:bodyPr>
+          <a:lstStyle/>
+          <a:p>
             <a:pPr>
               <a:buNone/>
               <a:defRPr sz="1200" b="0">
@@ -14986,7 +15135,7 @@
                 <a:ea typeface="Helvetica Neue"/>
                 <a:cs typeface="Helvetica Neue"/>
               </a:rPr>
-              <a:t>Evidence: tests/operator_review_rehearsal_20261004.md. A simulated test flag is not human audio confirmation.</a:t>
+              <a:t>Saved crossing edit observed. Slider listening, Restore and restart remain live checks.</a:t>
             </a:r>
           </a:p>
         </p:txBody>
@@ -14994,7 +15143,7 @@
     </p:spTree>
     <p:extLst>
       <p:ext uri="{BB962C8B-B14F-4D97-AF65-F5344CB8AC3E}">
-        <p14:creationId xmlns:p14="http://schemas.microsoft.com/office/powerpoint/2010/main" val="1065118661"/>
+        <ns3:creationId val="1065118661"/>
       </p:ext>
     </p:extLst>
   </p:cSld>

</xml_diff>

<commit_message>
feat: synchronize review audio with transcript selection
</commit_message>
<xml_diff>
--- a/progress/sprint_2/sprint_2_increment_demo.pptx
+++ b/progress/sprint_2/sprint_2_increment_demo.pptx
@@ -1862,7 +1862,7 @@
           <a:lstStyle/>
           <a:p>
             <a:r>
-              <a:t>Selected-text design accepted on 2026-10-04. BUG-6 exposed word-sized playback; BUG-7 exposed rejection of crossing corrections. Exact selected wording now changes while unselected words and superseded history stay saved. A saved native crossing edit was observed read-only in the Product Owner session: tests/selection_owner_session_20261004.json. All six selection_compatibility_verified gates passed at 20261004_230115. Source timing remains original-part resolution, with no invented replacement-word times. Context defaults to 2 seconds each side and is configurable. BUG-8 exposed a 33.28-second pause within the same S1 card. The directed repair adds a configurable long-silence boundary and a full-recording slider to both review and correction sheet. Dragging pauses/cancels bounded playback; release seeks; Play from position resumes. Demonstrate actual listening, scrubbing, Save, Restore, Cancel and restart. The separate QA-window launch was declined; native slider/audio verification remains pending. CLI shown is single-source only outside active ranges; range editing uses GUI. No ASR/LLM inference quality improvement is claimed. Evidence: sprint_2_tests.md; tests/selection_correction_review_20261004.json; tests/long_silence_review_20261004.json.</a:t>
+              <a:t>Selected-text design accepted on 2026-10-04. BUG-6 exposed word-sized playback; BUG-7 exposed rejection of crossing corrections. Exact selected wording now changes while unselected words and superseded history stay saved. A saved native crossing edit was observed read-only in the Product Owner session: tests/selection_owner_session_20261004.json. All six selection_compatibility_verified gates passed at 20261004_230115. Source timing remains original-part resolution, with no invented replacement-word times. Context defaults to 2 seconds each side and is configurable. BUG-8 exposed a 33.28-second pause within the same S1 card. The directed repair adds a configurable long-silence boundary and a full-recording slider to both review and correction sheet. Dragging pauses/cancels bounded playback; release seeks; Play from position resumes. Demonstrate actual listening, scrubbing, Save, Restore, Cancel and restart. The separate QA-window launch was declined; native slider/audio verification remains pending. CLI shown is single-source only outside active ranges; range editing uses GUI. No ASR/LLM inference quality improvement is claimed. Evidence: sprint_2_tests.md; tests/selection_correction_review_20261004.json; tests/long_silence_review_20261004.json. Bidirectional synchronization was explicitly accepted by the Product Owner. ReviewPlayback exposes media time and a transient slider preview; TranscriptAudioIndex maps shared RangeProjection spans. Temporary text highlighting is independent of native correction selection. Playback or slider movement marks matching text and follows it; selecting a nonempty phrase pauses and seeks to its first mapped source start. Show the real 148.40–181.68 s gap with no highlight, then select the post-gap W(it)am source at 181.68 s. Corrected paragraphs have one shared original source interval, not invented replacement-word times; a phrase inside the earlier corrected paragraph seeks to 134.88 s. Internal untimed gaps remain unmarked. UT-22/IT-17 test mapping and store rebuilding. Native listening, mouse/keyboard selection and scrolling still require the live check; no GUI rehearsal is claimed. See tests/transcript_audio_sync_review_20261004.json and user_manual.md#synchronize-audio-and-transcript-text.</a:t>
             </a:r>
           </a:p>
         </p:txBody>
@@ -14233,7 +14233,7 @@
                 <a:ea typeface="Helvetica Neue"/>
                 <a:cs typeface="Helvetica Neue"/>
               </a:rPr>
-              <a:t>Correction of a selected transcript phrase</a:t>
+              <a:t>Follow audio, select text, correct a phrase</a:t>
             </a:r>
           </a:p>
         </p:txBody>
@@ -14325,7 +14325,7 @@
                 <a:ea typeface="Helvetica Neue"/>
                 <a:cs typeface="Helvetica Neue"/>
               </a:rPr>
-              <a:t>1. Select and listen</a:t>
+              <a:t>1. Audio ↔ text</a:t>
             </a:r>
           </a:p>
         </p:txBody>
@@ -14383,7 +14383,7 @@
                 <a:ea typeface="Helvetica Neue"/>
                 <a:cs typeface="Helvetica Neue"/>
               </a:rPr>
-              <a:t>Select phrase; Correct selection.</a:t>
+              <a:t>Play: yellow text follows.</a:t>
             </a:r>
           </a:p>
           <a:p>
@@ -14407,7 +14407,7 @@
                 <a:ea typeface="Helvetica Neue"/>
                 <a:cs typeface="Helvetica Neue"/>
               </a:rPr>
-              <a:t>Set audio before and after.</a:t>
+              <a:t>Drag: mark the timed text.</a:t>
             </a:r>
           </a:p>
           <a:p>
@@ -14431,7 +14431,7 @@
                 <a:ea typeface="Helvetica Neue"/>
                 <a:cs typeface="Helvetica Neue"/>
               </a:rPr>
-              <a:t>Play selection with context.</a:t>
+              <a:t>Silence: no highlighted text.</a:t>
             </a:r>
           </a:p>
           <a:p>
@@ -14455,7 +14455,7 @@
                 <a:ea typeface="Helvetica Neue"/>
                 <a:cs typeface="Helvetica Neue"/>
               </a:rPr>
-              <a:t>Use slider to inspect silence.</a:t>
+              <a:t>Select phrase: seek and pause.</a:t>
             </a:r>
           </a:p>
           <a:p>
@@ -14479,7 +14479,7 @@
                 <a:ea typeface="Helvetica Neue"/>
                 <a:cs typeface="Helvetica Neue"/>
               </a:rPr>
-              <a:t>Check the recorded words.</a:t>
+              <a:t>Play resumes from there.</a:t>
             </a:r>
           </a:p>
         </p:txBody>
@@ -14571,7 +14571,7 @@
                 <a:ea typeface="Helvetica Neue"/>
                 <a:cs typeface="Helvetica Neue"/>
               </a:rPr>
-              <a:t>2. Save the correction</a:t>
+              <a:t>2. Listen and save</a:t>
             </a:r>
           </a:p>
         </p:txBody>
@@ -14629,7 +14629,7 @@
                 <a:ea typeface="Helvetica Neue"/>
                 <a:cs typeface="Helvetica Neue"/>
               </a:rPr>
-              <a:t>Edit the selected phrase.</a:t>
+              <a:t>Choose Correct selection.</a:t>
             </a:r>
           </a:p>
           <a:p>
@@ -14653,7 +14653,7 @@
                 <a:ea typeface="Helvetica Neue"/>
                 <a:cs typeface="Helvetica Neue"/>
               </a:rPr>
-              <a:t>Confirm that you listened.</a:t>
+              <a:t>Play with before/after context.</a:t>
             </a:r>
           </a:p>
           <a:p>
@@ -14677,7 +14677,7 @@
                 <a:ea typeface="Helvetica Neue"/>
                 <a:cs typeface="Helvetica Neue"/>
               </a:rPr>
-              <a:t>Click Save correction.</a:t>
+              <a:t>Edit; confirm listening; Save.</a:t>
             </a:r>
           </a:p>
           <a:p>
@@ -15135,7 +15135,7 @@
                 <a:ea typeface="Helvetica Neue"/>
                 <a:cs typeface="Helvetica Neue"/>
               </a:rPr>
-              <a:t>Saved crossing edit observed. Slider listening, Restore and restart remain live checks.</a:t>
+              <a:t>Corrected range: one shared time span. Native audio/highlight checks remain pending.</a:t>
             </a:r>
           </a:p>
         </p:txBody>

</xml_diff>